<commit_message>
fix(exports): align PPTX/PDF with web deck layout and typography
Shared header rule, cream/white card panels, serif+sans pairing (Georgia/Calibri in PPT, Times/Helvetica in PDF), 16:9 PDF canvas, centered title slide. Regenerated export artifacts.
</commit_message>
<xml_diff>
--- a/export/ClosetAI-ENSF400-Group12.pptx
+++ b/export/ClosetAI-ENSF400-Group12.pptx
@@ -1417,8 +1417,8 @@
         </p:nvSpPr>
         <p:spPr>
           <a:xfrm>
-            <a:off x="457200" y="1645920"/>
-            <a:ext cx="8229600" cy="1097280"/>
+            <a:off x="731520" y="1508760"/>
+            <a:ext cx="7680960" cy="868680"/>
           </a:xfrm>
           <a:prstGeom prst="rect">
             <a:avLst/>
@@ -1434,17 +1434,17 @@
               <a:buNone/>
             </a:pPr>
             <a:r>
-              <a:rPr lang="en-US" sz="5400" b="1" dirty="0">
+              <a:rPr lang="en-US" sz="5200" b="1" dirty="0">
                 <a:solidFill>
                   <a:srgbClr val="0A0A0A"/>
                 </a:solidFill>
-                <a:latin typeface="Arial" pitchFamily="34" charset="0"/>
-                <a:ea typeface="Arial" pitchFamily="34" charset="-122"/>
-                <a:cs typeface="Arial" pitchFamily="34" charset="-120"/>
+                <a:latin typeface="Georgia" pitchFamily="34" charset="0"/>
+                <a:ea typeface="Georgia" pitchFamily="34" charset="-122"/>
+                <a:cs typeface="Georgia" pitchFamily="34" charset="-120"/>
               </a:rPr>
               <a:t>ClosetAI</a:t>
             </a:r>
-            <a:endParaRPr lang="en-US" sz="5400" dirty="0"/>
+            <a:endParaRPr lang="en-US" sz="5200" dirty="0"/>
           </a:p>
         </p:txBody>
       </p:sp>
@@ -1456,8 +1456,8 @@
         </p:nvSpPr>
         <p:spPr>
           <a:xfrm>
-            <a:off x="914400" y="2834640"/>
-            <a:ext cx="7315200" cy="1371600"/>
+            <a:off x="1097280" y="2606040"/>
+            <a:ext cx="6949440" cy="1234440"/>
           </a:xfrm>
           <a:prstGeom prst="rect">
             <a:avLst/>
@@ -1473,17 +1473,17 @@
               <a:buNone/>
             </a:pPr>
             <a:r>
-              <a:rPr lang="en-US" sz="2000" dirty="0">
-                <a:solidFill>
-                  <a:srgbClr val="5C5C5C"/>
-                </a:solidFill>
-                <a:latin typeface="Arial" pitchFamily="34" charset="0"/>
-                <a:ea typeface="Arial" pitchFamily="34" charset="-122"/>
-                <a:cs typeface="Arial" pitchFamily="34" charset="-120"/>
+              <a:rPr lang="en-US" sz="1900" dirty="0">
+                <a:solidFill>
+                  <a:srgbClr val="6A6A6A"/>
+                </a:solidFill>
+                <a:latin typeface="Calibri" pitchFamily="34" charset="0"/>
+                <a:ea typeface="Calibri" pitchFamily="34" charset="-122"/>
+                <a:cs typeface="Calibri" pitchFamily="34" charset="-120"/>
               </a:rPr>
               <a:t>Digitize your closet and get outfit ideas from what you already own, with clear reasoning.</a:t>
             </a:r>
-            <a:endParaRPr lang="en-US" sz="2000" dirty="0"/>
+            <a:endParaRPr lang="en-US" sz="1900" dirty="0"/>
           </a:p>
         </p:txBody>
       </p:sp>
@@ -1495,8 +1495,8 @@
         </p:nvSpPr>
         <p:spPr>
           <a:xfrm>
-            <a:off x="457200" y="5303520"/>
-            <a:ext cx="8229600" cy="0"/>
+            <a:off x="731520" y="5532120"/>
+            <a:ext cx="7680960" cy="411480"/>
           </a:xfrm>
           <a:prstGeom prst="rect">
             <a:avLst/>
@@ -1512,17 +1512,17 @@
               <a:buNone/>
             </a:pPr>
             <a:r>
-              <a:rPr lang="en-US" sz="1200" dirty="0">
-                <a:solidFill>
-                  <a:srgbClr val="5C5C5C"/>
-                </a:solidFill>
-                <a:latin typeface="Arial" pitchFamily="34" charset="0"/>
-                <a:ea typeface="Arial" pitchFamily="34" charset="-122"/>
-                <a:cs typeface="Arial" pitchFamily="34" charset="-120"/>
-              </a:rPr>
-              <a:t>ENSF 400: Software Engineering · Section L01   ·   Group 12</a:t>
-            </a:r>
-            <a:endParaRPr lang="en-US" sz="1200" dirty="0"/>
+              <a:rPr lang="en-US" sz="1100" dirty="0">
+                <a:solidFill>
+                  <a:srgbClr val="6A6A6A"/>
+                </a:solidFill>
+                <a:latin typeface="Calibri" pitchFamily="34" charset="0"/>
+                <a:ea typeface="Calibri" pitchFamily="34" charset="-122"/>
+                <a:cs typeface="Calibri" pitchFamily="34" charset="-120"/>
+              </a:rPr>
+              <a:t>ENSF 400: Software Engineering · Section L01     ·     Group 12</a:t>
+            </a:r>
+            <a:endParaRPr lang="en-US" sz="1100" dirty="0"/>
           </a:p>
         </p:txBody>
       </p:sp>
@@ -1566,8 +1566,8 @@
         </p:nvSpPr>
         <p:spPr>
           <a:xfrm>
-            <a:off x="457200" y="411480"/>
-            <a:ext cx="3657600" cy="320040"/>
+            <a:off x="502920" y="347472"/>
+            <a:ext cx="3657600" cy="256032"/>
           </a:xfrm>
           <a:prstGeom prst="rect">
             <a:avLst/>
@@ -1583,17 +1583,17 @@
               <a:buNone/>
             </a:pPr>
             <a:r>
-              <a:rPr lang="en-US" sz="1100" dirty="0">
-                <a:solidFill>
-                  <a:srgbClr val="5C5C5C"/>
-                </a:solidFill>
-                <a:latin typeface="Arial" pitchFamily="34" charset="0"/>
-                <a:ea typeface="Arial" pitchFamily="34" charset="-122"/>
-                <a:cs typeface="Arial" pitchFamily="34" charset="-120"/>
-              </a:rPr>
-              <a:t>Group 12</a:t>
-            </a:r>
-            <a:endParaRPr lang="en-US" sz="1100" dirty="0"/>
+              <a:rPr lang="en-US" sz="1000" dirty="0">
+                <a:solidFill>
+                  <a:srgbClr val="6A6A6A"/>
+                </a:solidFill>
+                <a:latin typeface="Calibri" pitchFamily="34" charset="0"/>
+                <a:ea typeface="Calibri" pitchFamily="34" charset="-122"/>
+                <a:cs typeface="Calibri" pitchFamily="34" charset="-120"/>
+              </a:rPr>
+              <a:t>GROUP 12</a:t>
+            </a:r>
+            <a:endParaRPr lang="en-US" sz="1000" dirty="0"/>
           </a:p>
         </p:txBody>
       </p:sp>
@@ -1605,8 +1605,8 @@
         </p:nvSpPr>
         <p:spPr>
           <a:xfrm>
-            <a:off x="457200" y="685800"/>
-            <a:ext cx="10972800" cy="731520"/>
+            <a:off x="502920" y="566928"/>
+            <a:ext cx="11292840" cy="658368"/>
           </a:xfrm>
           <a:prstGeom prst="rect">
             <a:avLst/>
@@ -1622,30 +1622,80 @@
               <a:buNone/>
             </a:pPr>
             <a:r>
-              <a:rPr lang="en-US" sz="3200" b="1" dirty="0">
+              <a:rPr lang="en-US" sz="3400" b="1" dirty="0">
                 <a:solidFill>
                   <a:srgbClr val="0A0A0A"/>
                 </a:solidFill>
-                <a:latin typeface="Arial" pitchFamily="34" charset="0"/>
-                <a:ea typeface="Arial" pitchFamily="34" charset="-122"/>
-                <a:cs typeface="Arial" pitchFamily="34" charset="-120"/>
+                <a:latin typeface="Georgia" pitchFamily="34" charset="0"/>
+                <a:ea typeface="Georgia" pitchFamily="34" charset="-122"/>
+                <a:cs typeface="Georgia" pitchFamily="34" charset="-120"/>
               </a:rPr>
               <a:t>Team</a:t>
             </a:r>
-            <a:endParaRPr lang="en-US" sz="3200" dirty="0"/>
-          </a:p>
-        </p:txBody>
-      </p:sp>
-      <p:sp>
-        <p:nvSpPr>
-          <p:cNvPr id="4" name="Text 2"/>
-          <p:cNvSpPr/>
-          <p:nvPr/>
-        </p:nvSpPr>
-        <p:spPr>
-          <a:xfrm>
-            <a:off x="502920" y="1691640"/>
-            <a:ext cx="5303520" cy="411480"/>
+            <a:endParaRPr lang="en-US" sz="3400" dirty="0"/>
+          </a:p>
+        </p:txBody>
+      </p:sp>
+      <p:sp>
+        <p:nvSpPr>
+          <p:cNvPr id="4" name="Shape 2"/>
+          <p:cNvSpPr/>
+          <p:nvPr/>
+        </p:nvSpPr>
+        <p:spPr>
+          <a:xfrm>
+            <a:off x="502920" y="1261872"/>
+            <a:ext cx="11292840" cy="0"/>
+          </a:xfrm>
+          <a:prstGeom prst="line">
+            <a:avLst/>
+          </a:prstGeom>
+          <a:noFill/>
+          <a:ln w="12700">
+            <a:solidFill>
+              <a:srgbClr val="E6E6E6"/>
+            </a:solidFill>
+            <a:prstDash val="solid"/>
+          </a:ln>
+        </p:spPr>
+      </p:sp>
+      <p:sp>
+        <p:nvSpPr>
+          <p:cNvPr id="5" name="Shape 3"/>
+          <p:cNvSpPr/>
+          <p:nvPr/>
+        </p:nvSpPr>
+        <p:spPr>
+          <a:xfrm>
+            <a:off x="448056" y="1389888"/>
+            <a:ext cx="5550408" cy="1371600"/>
+          </a:xfrm>
+          <a:prstGeom prst="roundRect">
+            <a:avLst>
+              <a:gd name="adj" fmla="val 8000"/>
+            </a:avLst>
+          </a:prstGeom>
+          <a:solidFill>
+            <a:srgbClr val="FFFFFF"/>
+          </a:solidFill>
+          <a:ln w="12700">
+            <a:solidFill>
+              <a:srgbClr val="E6E6E6"/>
+            </a:solidFill>
+            <a:prstDash val="solid"/>
+          </a:ln>
+        </p:spPr>
+      </p:sp>
+      <p:sp>
+        <p:nvSpPr>
+          <p:cNvPr id="6" name="Text 4"/>
+          <p:cNvSpPr/>
+          <p:nvPr/>
+        </p:nvSpPr>
+        <p:spPr>
+          <a:xfrm>
+            <a:off x="685800" y="1554480"/>
+            <a:ext cx="5074920" cy="347472"/>
           </a:xfrm>
           <a:prstGeom prst="rect">
             <a:avLst/>
@@ -1661,30 +1711,30 @@
               <a:buNone/>
             </a:pPr>
             <a:r>
-              <a:rPr lang="en-US" sz="2000" b="1" dirty="0">
+              <a:rPr lang="en-US" sz="1900" b="1" dirty="0">
                 <a:solidFill>
                   <a:srgbClr val="0A0A0A"/>
                 </a:solidFill>
-                <a:latin typeface="Arial" pitchFamily="34" charset="0"/>
-                <a:ea typeface="Arial" pitchFamily="34" charset="-122"/>
-                <a:cs typeface="Arial" pitchFamily="34" charset="-120"/>
+                <a:latin typeface="Georgia" pitchFamily="34" charset="0"/>
+                <a:ea typeface="Georgia" pitchFamily="34" charset="-122"/>
+                <a:cs typeface="Georgia" pitchFamily="34" charset="-120"/>
               </a:rPr>
               <a:t>Ali Chaudhary</a:t>
             </a:r>
-            <a:endParaRPr lang="en-US" sz="2000" dirty="0"/>
-          </a:p>
-        </p:txBody>
-      </p:sp>
-      <p:sp>
-        <p:nvSpPr>
-          <p:cNvPr id="5" name="Text 3"/>
-          <p:cNvSpPr/>
-          <p:nvPr/>
-        </p:nvSpPr>
-        <p:spPr>
-          <a:xfrm>
-            <a:off x="502920" y="2075688"/>
-            <a:ext cx="5303520" cy="320040"/>
+            <a:endParaRPr lang="en-US" sz="1900" dirty="0"/>
+          </a:p>
+        </p:txBody>
+      </p:sp>
+      <p:sp>
+        <p:nvSpPr>
+          <p:cNvPr id="7" name="Text 5"/>
+          <p:cNvSpPr/>
+          <p:nvPr/>
+        </p:nvSpPr>
+        <p:spPr>
+          <a:xfrm>
+            <a:off x="685800" y="1847088"/>
+            <a:ext cx="5074920" cy="256032"/>
           </a:xfrm>
           <a:prstGeom prst="rect">
             <a:avLst/>
@@ -1700,30 +1750,30 @@
               <a:buNone/>
             </a:pPr>
             <a:r>
-              <a:rPr lang="en-US" sz="1500" dirty="0">
-                <a:solidFill>
-                  <a:srgbClr val="5C5C5C"/>
-                </a:solidFill>
-                <a:latin typeface="Arial" pitchFamily="34" charset="0"/>
-                <a:ea typeface="Arial" pitchFamily="34" charset="-122"/>
-                <a:cs typeface="Arial" pitchFamily="34" charset="-120"/>
+              <a:rPr lang="en-US" sz="1300" dirty="0">
+                <a:solidFill>
+                  <a:srgbClr val="6A6A6A"/>
+                </a:solidFill>
+                <a:latin typeface="Calibri" pitchFamily="34" charset="0"/>
+                <a:ea typeface="Calibri" pitchFamily="34" charset="-122"/>
+                <a:cs typeface="Calibri" pitchFamily="34" charset="-120"/>
               </a:rPr>
               <a:t>Team Lead</a:t>
             </a:r>
-            <a:endParaRPr lang="en-US" sz="1500" dirty="0"/>
-          </a:p>
-        </p:txBody>
-      </p:sp>
-      <p:sp>
-        <p:nvSpPr>
-          <p:cNvPr id="6" name="Text 4"/>
-          <p:cNvSpPr/>
-          <p:nvPr/>
-        </p:nvSpPr>
-        <p:spPr>
-          <a:xfrm>
-            <a:off x="502920" y="2404872"/>
-            <a:ext cx="5303520" cy="274320"/>
+            <a:endParaRPr lang="en-US" sz="1300" dirty="0"/>
+          </a:p>
+        </p:txBody>
+      </p:sp>
+      <p:sp>
+        <p:nvSpPr>
+          <p:cNvPr id="8" name="Text 6"/>
+          <p:cNvSpPr/>
+          <p:nvPr/>
+        </p:nvSpPr>
+        <p:spPr>
+          <a:xfrm>
+            <a:off x="685800" y="2139696"/>
+            <a:ext cx="5074920" cy="237744"/>
           </a:xfrm>
           <a:prstGeom prst="rect">
             <a:avLst/>
@@ -1739,30 +1789,57 @@
               <a:buNone/>
             </a:pPr>
             <a:r>
-              <a:rPr lang="en-US" sz="1100" dirty="0">
-                <a:solidFill>
-                  <a:srgbClr val="5C5C5C"/>
-                </a:solidFill>
-                <a:latin typeface="Arial" pitchFamily="34" charset="0"/>
-                <a:ea typeface="Arial" pitchFamily="34" charset="-122"/>
-                <a:cs typeface="Arial" pitchFamily="34" charset="-120"/>
+              <a:rPr lang="en-US" sz="1000" dirty="0">
+                <a:solidFill>
+                  <a:srgbClr val="6A6A6A"/>
+                </a:solidFill>
+                <a:latin typeface="Calibri" pitchFamily="34" charset="0"/>
+                <a:ea typeface="Calibri" pitchFamily="34" charset="-122"/>
+                <a:cs typeface="Calibri" pitchFamily="34" charset="-120"/>
               </a:rPr>
               <a:t>UCID 30204228</a:t>
             </a:r>
-            <a:endParaRPr lang="en-US" sz="1100" dirty="0"/>
-          </a:p>
-        </p:txBody>
-      </p:sp>
-      <p:sp>
-        <p:nvSpPr>
-          <p:cNvPr id="7" name="Text 5"/>
-          <p:cNvSpPr/>
-          <p:nvPr/>
-        </p:nvSpPr>
-        <p:spPr>
-          <a:xfrm>
-            <a:off x="6172200" y="1691640"/>
-            <a:ext cx="5303520" cy="411480"/>
+            <a:endParaRPr lang="en-US" sz="1000" dirty="0"/>
+          </a:p>
+        </p:txBody>
+      </p:sp>
+      <p:sp>
+        <p:nvSpPr>
+          <p:cNvPr id="9" name="Shape 7"/>
+          <p:cNvSpPr/>
+          <p:nvPr/>
+        </p:nvSpPr>
+        <p:spPr>
+          <a:xfrm>
+            <a:off x="6208776" y="1389888"/>
+            <a:ext cx="5550408" cy="1371600"/>
+          </a:xfrm>
+          <a:prstGeom prst="roundRect">
+            <a:avLst>
+              <a:gd name="adj" fmla="val 8000"/>
+            </a:avLst>
+          </a:prstGeom>
+          <a:solidFill>
+            <a:srgbClr val="FFFFFF"/>
+          </a:solidFill>
+          <a:ln w="12700">
+            <a:solidFill>
+              <a:srgbClr val="E6E6E6"/>
+            </a:solidFill>
+            <a:prstDash val="solid"/>
+          </a:ln>
+        </p:spPr>
+      </p:sp>
+      <p:sp>
+        <p:nvSpPr>
+          <p:cNvPr id="10" name="Text 8"/>
+          <p:cNvSpPr/>
+          <p:nvPr/>
+        </p:nvSpPr>
+        <p:spPr>
+          <a:xfrm>
+            <a:off x="6446520" y="1554480"/>
+            <a:ext cx="5074920" cy="347472"/>
           </a:xfrm>
           <a:prstGeom prst="rect">
             <a:avLst/>
@@ -1778,30 +1855,30 @@
               <a:buNone/>
             </a:pPr>
             <a:r>
-              <a:rPr lang="en-US" sz="2000" b="1" dirty="0">
+              <a:rPr lang="en-US" sz="1900" b="1" dirty="0">
                 <a:solidFill>
                   <a:srgbClr val="0A0A0A"/>
                 </a:solidFill>
-                <a:latin typeface="Arial" pitchFamily="34" charset="0"/>
-                <a:ea typeface="Arial" pitchFamily="34" charset="-122"/>
-                <a:cs typeface="Arial" pitchFamily="34" charset="-120"/>
+                <a:latin typeface="Georgia" pitchFamily="34" charset="0"/>
+                <a:ea typeface="Georgia" pitchFamily="34" charset="-122"/>
+                <a:cs typeface="Georgia" pitchFamily="34" charset="-120"/>
               </a:rPr>
               <a:t>Tyseer Shahriar</a:t>
             </a:r>
-            <a:endParaRPr lang="en-US" sz="2000" dirty="0"/>
-          </a:p>
-        </p:txBody>
-      </p:sp>
-      <p:sp>
-        <p:nvSpPr>
-          <p:cNvPr id="8" name="Text 6"/>
-          <p:cNvSpPr/>
-          <p:nvPr/>
-        </p:nvSpPr>
-        <p:spPr>
-          <a:xfrm>
-            <a:off x="6172200" y="2103120"/>
-            <a:ext cx="5303520" cy="274320"/>
+            <a:endParaRPr lang="en-US" sz="1900" dirty="0"/>
+          </a:p>
+        </p:txBody>
+      </p:sp>
+      <p:sp>
+        <p:nvSpPr>
+          <p:cNvPr id="11" name="Text 9"/>
+          <p:cNvSpPr/>
+          <p:nvPr/>
+        </p:nvSpPr>
+        <p:spPr>
+          <a:xfrm>
+            <a:off x="6446520" y="1847088"/>
+            <a:ext cx="5074920" cy="237744"/>
           </a:xfrm>
           <a:prstGeom prst="rect">
             <a:avLst/>
@@ -1817,30 +1894,57 @@
               <a:buNone/>
             </a:pPr>
             <a:r>
-              <a:rPr lang="en-US" sz="1100" dirty="0">
-                <a:solidFill>
-                  <a:srgbClr val="5C5C5C"/>
-                </a:solidFill>
-                <a:latin typeface="Arial" pitchFamily="34" charset="0"/>
-                <a:ea typeface="Arial" pitchFamily="34" charset="-122"/>
-                <a:cs typeface="Arial" pitchFamily="34" charset="-120"/>
+              <a:rPr lang="en-US" sz="1000" dirty="0">
+                <a:solidFill>
+                  <a:srgbClr val="6A6A6A"/>
+                </a:solidFill>
+                <a:latin typeface="Calibri" pitchFamily="34" charset="0"/>
+                <a:ea typeface="Calibri" pitchFamily="34" charset="-122"/>
+                <a:cs typeface="Calibri" pitchFamily="34" charset="-120"/>
               </a:rPr>
               <a:t>UCID 30206937</a:t>
             </a:r>
-            <a:endParaRPr lang="en-US" sz="1100" dirty="0"/>
-          </a:p>
-        </p:txBody>
-      </p:sp>
-      <p:sp>
-        <p:nvSpPr>
-          <p:cNvPr id="9" name="Text 7"/>
-          <p:cNvSpPr/>
-          <p:nvPr/>
-        </p:nvSpPr>
-        <p:spPr>
-          <a:xfrm>
-            <a:off x="502920" y="3108960"/>
-            <a:ext cx="5303520" cy="411480"/>
+            <a:endParaRPr lang="en-US" sz="1000" dirty="0"/>
+          </a:p>
+        </p:txBody>
+      </p:sp>
+      <p:sp>
+        <p:nvSpPr>
+          <p:cNvPr id="12" name="Shape 10"/>
+          <p:cNvSpPr/>
+          <p:nvPr/>
+        </p:nvSpPr>
+        <p:spPr>
+          <a:xfrm>
+            <a:off x="448056" y="2971800"/>
+            <a:ext cx="5550408" cy="1371600"/>
+          </a:xfrm>
+          <a:prstGeom prst="roundRect">
+            <a:avLst>
+              <a:gd name="adj" fmla="val 8000"/>
+            </a:avLst>
+          </a:prstGeom>
+          <a:solidFill>
+            <a:srgbClr val="FFFFFF"/>
+          </a:solidFill>
+          <a:ln w="12700">
+            <a:solidFill>
+              <a:srgbClr val="E6E6E6"/>
+            </a:solidFill>
+            <a:prstDash val="solid"/>
+          </a:ln>
+        </p:spPr>
+      </p:sp>
+      <p:sp>
+        <p:nvSpPr>
+          <p:cNvPr id="13" name="Text 11"/>
+          <p:cNvSpPr/>
+          <p:nvPr/>
+        </p:nvSpPr>
+        <p:spPr>
+          <a:xfrm>
+            <a:off x="685800" y="3136392"/>
+            <a:ext cx="5074920" cy="347472"/>
           </a:xfrm>
           <a:prstGeom prst="rect">
             <a:avLst/>
@@ -1856,30 +1960,30 @@
               <a:buNone/>
             </a:pPr>
             <a:r>
-              <a:rPr lang="en-US" sz="2000" b="1" dirty="0">
+              <a:rPr lang="en-US" sz="1900" b="1" dirty="0">
                 <a:solidFill>
                   <a:srgbClr val="0A0A0A"/>
                 </a:solidFill>
-                <a:latin typeface="Arial" pitchFamily="34" charset="0"/>
-                <a:ea typeface="Arial" pitchFamily="34" charset="-122"/>
-                <a:cs typeface="Arial" pitchFamily="34" charset="-120"/>
+                <a:latin typeface="Georgia" pitchFamily="34" charset="0"/>
+                <a:ea typeface="Georgia" pitchFamily="34" charset="-122"/>
+                <a:cs typeface="Georgia" pitchFamily="34" charset="-120"/>
               </a:rPr>
               <a:t>Mujtaba Zia</a:t>
             </a:r>
-            <a:endParaRPr lang="en-US" sz="2000" dirty="0"/>
-          </a:p>
-        </p:txBody>
-      </p:sp>
-      <p:sp>
-        <p:nvSpPr>
-          <p:cNvPr id="10" name="Text 8"/>
-          <p:cNvSpPr/>
-          <p:nvPr/>
-        </p:nvSpPr>
-        <p:spPr>
-          <a:xfrm>
-            <a:off x="502920" y="3520440"/>
-            <a:ext cx="5303520" cy="274320"/>
+            <a:endParaRPr lang="en-US" sz="1900" dirty="0"/>
+          </a:p>
+        </p:txBody>
+      </p:sp>
+      <p:sp>
+        <p:nvSpPr>
+          <p:cNvPr id="14" name="Text 12"/>
+          <p:cNvSpPr/>
+          <p:nvPr/>
+        </p:nvSpPr>
+        <p:spPr>
+          <a:xfrm>
+            <a:off x="685800" y="3429000"/>
+            <a:ext cx="5074920" cy="237744"/>
           </a:xfrm>
           <a:prstGeom prst="rect">
             <a:avLst/>
@@ -1895,30 +1999,57 @@
               <a:buNone/>
             </a:pPr>
             <a:r>
-              <a:rPr lang="en-US" sz="1100" dirty="0">
-                <a:solidFill>
-                  <a:srgbClr val="5C5C5C"/>
-                </a:solidFill>
-                <a:latin typeface="Arial" pitchFamily="34" charset="0"/>
-                <a:ea typeface="Arial" pitchFamily="34" charset="-122"/>
-                <a:cs typeface="Arial" pitchFamily="34" charset="-120"/>
+              <a:rPr lang="en-US" sz="1000" dirty="0">
+                <a:solidFill>
+                  <a:srgbClr val="6A6A6A"/>
+                </a:solidFill>
+                <a:latin typeface="Calibri" pitchFamily="34" charset="0"/>
+                <a:ea typeface="Calibri" pitchFamily="34" charset="-122"/>
+                <a:cs typeface="Calibri" pitchFamily="34" charset="-120"/>
               </a:rPr>
               <a:t>UCID 30229568</a:t>
             </a:r>
-            <a:endParaRPr lang="en-US" sz="1100" dirty="0"/>
-          </a:p>
-        </p:txBody>
-      </p:sp>
-      <p:sp>
-        <p:nvSpPr>
-          <p:cNvPr id="11" name="Text 9"/>
-          <p:cNvSpPr/>
-          <p:nvPr/>
-        </p:nvSpPr>
-        <p:spPr>
-          <a:xfrm>
-            <a:off x="6172200" y="3108960"/>
-            <a:ext cx="5303520" cy="411480"/>
+            <a:endParaRPr lang="en-US" sz="1000" dirty="0"/>
+          </a:p>
+        </p:txBody>
+      </p:sp>
+      <p:sp>
+        <p:nvSpPr>
+          <p:cNvPr id="15" name="Shape 13"/>
+          <p:cNvSpPr/>
+          <p:nvPr/>
+        </p:nvSpPr>
+        <p:spPr>
+          <a:xfrm>
+            <a:off x="6208776" y="2971800"/>
+            <a:ext cx="5550408" cy="1371600"/>
+          </a:xfrm>
+          <a:prstGeom prst="roundRect">
+            <a:avLst>
+              <a:gd name="adj" fmla="val 8000"/>
+            </a:avLst>
+          </a:prstGeom>
+          <a:solidFill>
+            <a:srgbClr val="FFFFFF"/>
+          </a:solidFill>
+          <a:ln w="12700">
+            <a:solidFill>
+              <a:srgbClr val="E6E6E6"/>
+            </a:solidFill>
+            <a:prstDash val="solid"/>
+          </a:ln>
+        </p:spPr>
+      </p:sp>
+      <p:sp>
+        <p:nvSpPr>
+          <p:cNvPr id="16" name="Text 14"/>
+          <p:cNvSpPr/>
+          <p:nvPr/>
+        </p:nvSpPr>
+        <p:spPr>
+          <a:xfrm>
+            <a:off x="6446520" y="3136392"/>
+            <a:ext cx="5074920" cy="347472"/>
           </a:xfrm>
           <a:prstGeom prst="rect">
             <a:avLst/>
@@ -1934,30 +2065,30 @@
               <a:buNone/>
             </a:pPr>
             <a:r>
-              <a:rPr lang="en-US" sz="2000" b="1" dirty="0">
+              <a:rPr lang="en-US" sz="1900" b="1" dirty="0">
                 <a:solidFill>
                   <a:srgbClr val="0A0A0A"/>
                 </a:solidFill>
-                <a:latin typeface="Arial" pitchFamily="34" charset="0"/>
-                <a:ea typeface="Arial" pitchFamily="34" charset="-122"/>
-                <a:cs typeface="Arial" pitchFamily="34" charset="-120"/>
+                <a:latin typeface="Georgia" pitchFamily="34" charset="0"/>
+                <a:ea typeface="Georgia" pitchFamily="34" charset="-122"/>
+                <a:cs typeface="Georgia" pitchFamily="34" charset="-120"/>
               </a:rPr>
               <a:t>Yassin Soliman</a:t>
             </a:r>
-            <a:endParaRPr lang="en-US" sz="2000" dirty="0"/>
-          </a:p>
-        </p:txBody>
-      </p:sp>
-      <p:sp>
-        <p:nvSpPr>
-          <p:cNvPr id="12" name="Text 10"/>
-          <p:cNvSpPr/>
-          <p:nvPr/>
-        </p:nvSpPr>
-        <p:spPr>
-          <a:xfrm>
-            <a:off x="6172200" y="3520440"/>
-            <a:ext cx="5303520" cy="274320"/>
+            <a:endParaRPr lang="en-US" sz="1900" dirty="0"/>
+          </a:p>
+        </p:txBody>
+      </p:sp>
+      <p:sp>
+        <p:nvSpPr>
+          <p:cNvPr id="17" name="Text 15"/>
+          <p:cNvSpPr/>
+          <p:nvPr/>
+        </p:nvSpPr>
+        <p:spPr>
+          <a:xfrm>
+            <a:off x="6446520" y="3429000"/>
+            <a:ext cx="5074920" cy="237744"/>
           </a:xfrm>
           <a:prstGeom prst="rect">
             <a:avLst/>
@@ -1973,30 +2104,57 @@
               <a:buNone/>
             </a:pPr>
             <a:r>
-              <a:rPr lang="en-US" sz="1100" dirty="0">
-                <a:solidFill>
-                  <a:srgbClr val="5C5C5C"/>
-                </a:solidFill>
-                <a:latin typeface="Arial" pitchFamily="34" charset="0"/>
-                <a:ea typeface="Arial" pitchFamily="34" charset="-122"/>
-                <a:cs typeface="Arial" pitchFamily="34" charset="-120"/>
+              <a:rPr lang="en-US" sz="1000" dirty="0">
+                <a:solidFill>
+                  <a:srgbClr val="6A6A6A"/>
+                </a:solidFill>
+                <a:latin typeface="Calibri" pitchFamily="34" charset="0"/>
+                <a:ea typeface="Calibri" pitchFamily="34" charset="-122"/>
+                <a:cs typeface="Calibri" pitchFamily="34" charset="-120"/>
               </a:rPr>
               <a:t>UCID 30205455</a:t>
             </a:r>
-            <a:endParaRPr lang="en-US" sz="1100" dirty="0"/>
-          </a:p>
-        </p:txBody>
-      </p:sp>
-      <p:sp>
-        <p:nvSpPr>
-          <p:cNvPr id="13" name="Text 11"/>
-          <p:cNvSpPr/>
-          <p:nvPr/>
-        </p:nvSpPr>
-        <p:spPr>
-          <a:xfrm>
-            <a:off x="502920" y="4526280"/>
-            <a:ext cx="5303520" cy="411480"/>
+            <a:endParaRPr lang="en-US" sz="1000" dirty="0"/>
+          </a:p>
+        </p:txBody>
+      </p:sp>
+      <p:sp>
+        <p:nvSpPr>
+          <p:cNvPr id="18" name="Shape 16"/>
+          <p:cNvSpPr/>
+          <p:nvPr/>
+        </p:nvSpPr>
+        <p:spPr>
+          <a:xfrm>
+            <a:off x="448056" y="4553712"/>
+            <a:ext cx="5550408" cy="1371600"/>
+          </a:xfrm>
+          <a:prstGeom prst="roundRect">
+            <a:avLst>
+              <a:gd name="adj" fmla="val 8000"/>
+            </a:avLst>
+          </a:prstGeom>
+          <a:solidFill>
+            <a:srgbClr val="FFFFFF"/>
+          </a:solidFill>
+          <a:ln w="12700">
+            <a:solidFill>
+              <a:srgbClr val="E6E6E6"/>
+            </a:solidFill>
+            <a:prstDash val="solid"/>
+          </a:ln>
+        </p:spPr>
+      </p:sp>
+      <p:sp>
+        <p:nvSpPr>
+          <p:cNvPr id="19" name="Text 17"/>
+          <p:cNvSpPr/>
+          <p:nvPr/>
+        </p:nvSpPr>
+        <p:spPr>
+          <a:xfrm>
+            <a:off x="685800" y="4718304"/>
+            <a:ext cx="5074920" cy="347472"/>
           </a:xfrm>
           <a:prstGeom prst="rect">
             <a:avLst/>
@@ -2012,30 +2170,30 @@
               <a:buNone/>
             </a:pPr>
             <a:r>
-              <a:rPr lang="en-US" sz="2000" b="1" dirty="0">
+              <a:rPr lang="en-US" sz="1900" b="1" dirty="0">
                 <a:solidFill>
                   <a:srgbClr val="0A0A0A"/>
                 </a:solidFill>
-                <a:latin typeface="Arial" pitchFamily="34" charset="0"/>
-                <a:ea typeface="Arial" pitchFamily="34" charset="-122"/>
-                <a:cs typeface="Arial" pitchFamily="34" charset="-120"/>
+                <a:latin typeface="Georgia" pitchFamily="34" charset="0"/>
+                <a:ea typeface="Georgia" pitchFamily="34" charset="-122"/>
+                <a:cs typeface="Georgia" pitchFamily="34" charset="-120"/>
               </a:rPr>
               <a:t>Mykola Viktorovskyi</a:t>
             </a:r>
-            <a:endParaRPr lang="en-US" sz="2000" dirty="0"/>
-          </a:p>
-        </p:txBody>
-      </p:sp>
-      <p:sp>
-        <p:nvSpPr>
-          <p:cNvPr id="14" name="Text 12"/>
-          <p:cNvSpPr/>
-          <p:nvPr/>
-        </p:nvSpPr>
-        <p:spPr>
-          <a:xfrm>
-            <a:off x="502920" y="4937760"/>
-            <a:ext cx="5303520" cy="274320"/>
+            <a:endParaRPr lang="en-US" sz="1900" dirty="0"/>
+          </a:p>
+        </p:txBody>
+      </p:sp>
+      <p:sp>
+        <p:nvSpPr>
+          <p:cNvPr id="20" name="Text 18"/>
+          <p:cNvSpPr/>
+          <p:nvPr/>
+        </p:nvSpPr>
+        <p:spPr>
+          <a:xfrm>
+            <a:off x="685800" y="5010912"/>
+            <a:ext cx="5074920" cy="237744"/>
           </a:xfrm>
           <a:prstGeom prst="rect">
             <a:avLst/>
@@ -2051,17 +2209,17 @@
               <a:buNone/>
             </a:pPr>
             <a:r>
-              <a:rPr lang="en-US" sz="1100" dirty="0">
-                <a:solidFill>
-                  <a:srgbClr val="5C5C5C"/>
-                </a:solidFill>
-                <a:latin typeface="Arial" pitchFamily="34" charset="0"/>
-                <a:ea typeface="Arial" pitchFamily="34" charset="-122"/>
-                <a:cs typeface="Arial" pitchFamily="34" charset="-120"/>
+              <a:rPr lang="en-US" sz="1000" dirty="0">
+                <a:solidFill>
+                  <a:srgbClr val="6A6A6A"/>
+                </a:solidFill>
+                <a:latin typeface="Calibri" pitchFamily="34" charset="0"/>
+                <a:ea typeface="Calibri" pitchFamily="34" charset="-122"/>
+                <a:cs typeface="Calibri" pitchFamily="34" charset="-120"/>
               </a:rPr>
               <a:t>UCID 30233216</a:t>
             </a:r>
-            <a:endParaRPr lang="en-US" sz="1100" dirty="0"/>
+            <a:endParaRPr lang="en-US" sz="1000" dirty="0"/>
           </a:p>
         </p:txBody>
       </p:sp>
@@ -2105,8 +2263,8 @@
         </p:nvSpPr>
         <p:spPr>
           <a:xfrm>
-            <a:off x="457200" y="411480"/>
-            <a:ext cx="4572000" cy="320040"/>
+            <a:off x="502920" y="347472"/>
+            <a:ext cx="3657600" cy="256032"/>
           </a:xfrm>
           <a:prstGeom prst="rect">
             <a:avLst/>
@@ -2122,17 +2280,17 @@
               <a:buNone/>
             </a:pPr>
             <a:r>
-              <a:rPr lang="en-US" sz="1100" dirty="0">
-                <a:solidFill>
-                  <a:srgbClr val="5C5C5C"/>
-                </a:solidFill>
-                <a:latin typeface="Arial" pitchFamily="34" charset="0"/>
-                <a:ea typeface="Arial" pitchFamily="34" charset="-122"/>
-                <a:cs typeface="Arial" pitchFamily="34" charset="-120"/>
+              <a:rPr lang="en-US" sz="1000" dirty="0">
+                <a:solidFill>
+                  <a:srgbClr val="6A6A6A"/>
+                </a:solidFill>
+                <a:latin typeface="Calibri" pitchFamily="34" charset="0"/>
+                <a:ea typeface="Calibri" pitchFamily="34" charset="-122"/>
+                <a:cs typeface="Calibri" pitchFamily="34" charset="-120"/>
               </a:rPr>
               <a:t>SRS (A1)</a:t>
             </a:r>
-            <a:endParaRPr lang="en-US" sz="1100" dirty="0"/>
+            <a:endParaRPr lang="en-US" sz="1000" dirty="0"/>
           </a:p>
         </p:txBody>
       </p:sp>
@@ -2144,8 +2302,8 @@
         </p:nvSpPr>
         <p:spPr>
           <a:xfrm>
-            <a:off x="457200" y="685800"/>
-            <a:ext cx="10972800" cy="777240"/>
+            <a:off x="502920" y="566928"/>
+            <a:ext cx="11292840" cy="658368"/>
           </a:xfrm>
           <a:prstGeom prst="rect">
             <a:avLst/>
@@ -2161,30 +2319,53 @@
               <a:buNone/>
             </a:pPr>
             <a:r>
-              <a:rPr lang="en-US" sz="3200" b="1" dirty="0">
+              <a:rPr lang="en-US" sz="3400" b="1" dirty="0">
                 <a:solidFill>
                   <a:srgbClr val="0A0A0A"/>
                 </a:solidFill>
-                <a:latin typeface="Arial" pitchFamily="34" charset="0"/>
-                <a:ea typeface="Arial" pitchFamily="34" charset="-122"/>
-                <a:cs typeface="Arial" pitchFamily="34" charset="-120"/>
+                <a:latin typeface="Georgia" pitchFamily="34" charset="0"/>
+                <a:ea typeface="Georgia" pitchFamily="34" charset="-122"/>
+                <a:cs typeface="Georgia" pitchFamily="34" charset="-120"/>
               </a:rPr>
               <a:t>Scope &amp; requirements</a:t>
             </a:r>
-            <a:endParaRPr lang="en-US" sz="3200" dirty="0"/>
-          </a:p>
-        </p:txBody>
-      </p:sp>
-      <p:sp>
-        <p:nvSpPr>
-          <p:cNvPr id="4" name="Text 2"/>
-          <p:cNvSpPr/>
-          <p:nvPr/>
-        </p:nvSpPr>
-        <p:spPr>
-          <a:xfrm>
-            <a:off x="502920" y="1600200"/>
-            <a:ext cx="5394960" cy="4114800"/>
+            <a:endParaRPr lang="en-US" sz="3400" dirty="0"/>
+          </a:p>
+        </p:txBody>
+      </p:sp>
+      <p:sp>
+        <p:nvSpPr>
+          <p:cNvPr id="4" name="Shape 2"/>
+          <p:cNvSpPr/>
+          <p:nvPr/>
+        </p:nvSpPr>
+        <p:spPr>
+          <a:xfrm>
+            <a:off x="502920" y="1261872"/>
+            <a:ext cx="11292840" cy="0"/>
+          </a:xfrm>
+          <a:prstGeom prst="line">
+            <a:avLst/>
+          </a:prstGeom>
+          <a:noFill/>
+          <a:ln w="12700">
+            <a:solidFill>
+              <a:srgbClr val="E6E6E6"/>
+            </a:solidFill>
+            <a:prstDash val="solid"/>
+          </a:ln>
+        </p:spPr>
+      </p:sp>
+      <p:sp>
+        <p:nvSpPr>
+          <p:cNvPr id="5" name="Text 3"/>
+          <p:cNvSpPr/>
+          <p:nvPr/>
+        </p:nvSpPr>
+        <p:spPr>
+          <a:xfrm>
+            <a:off x="502920" y="1444752"/>
+            <a:ext cx="4937760" cy="4434840"/>
           </a:xfrm>
           <a:prstGeom prst="rect">
             <a:avLst/>
@@ -2202,11 +2383,11 @@
             <a:r>
               <a:rPr lang="en-US" sz="1500" dirty="0">
                 <a:solidFill>
-                  <a:srgbClr val="5C5C5C"/>
-                </a:solidFill>
-                <a:latin typeface="Arial" pitchFamily="34" charset="0"/>
-                <a:ea typeface="Arial" pitchFamily="34" charset="-122"/>
-                <a:cs typeface="Arial" pitchFamily="34" charset="-120"/>
+                  <a:srgbClr val="6A6A6A"/>
+                </a:solidFill>
+                <a:latin typeface="Calibri" pitchFamily="34" charset="0"/>
+                <a:ea typeface="Calibri" pitchFamily="34" charset="-122"/>
+                <a:cs typeface="Calibri" pitchFamily="34" charset="-120"/>
               </a:rPr>
               <a:t>ClosetAI is a web app for digitizing clothes, managing a personal wardrobe, and generating outfits from items the user already owns, with explanations they can read and trust.</a:t>
             </a:r>
@@ -2216,14 +2397,14 @@
       </p:sp>
       <p:sp>
         <p:nvSpPr>
-          <p:cNvPr id="5" name="Text 3"/>
-          <p:cNvSpPr/>
-          <p:nvPr/>
-        </p:nvSpPr>
-        <p:spPr>
-          <a:xfrm>
-            <a:off x="6080760" y="1600200"/>
-            <a:ext cx="5669280" cy="320040"/>
+          <p:cNvPr id="6" name="Text 4"/>
+          <p:cNvSpPr/>
+          <p:nvPr/>
+        </p:nvSpPr>
+        <p:spPr>
+          <a:xfrm>
+            <a:off x="5623560" y="1444752"/>
+            <a:ext cx="6172200" cy="292608"/>
           </a:xfrm>
           <a:prstGeom prst="rect">
             <a:avLst/>
@@ -2239,30 +2420,30 @@
               <a:buNone/>
             </a:pPr>
             <a:r>
-              <a:rPr lang="en-US" sz="1200" b="1" dirty="0">
+              <a:rPr lang="en-US" sz="1000" b="1" dirty="0">
                 <a:solidFill>
                   <a:srgbClr val="1A1B3A"/>
                 </a:solidFill>
-                <a:latin typeface="Arial" pitchFamily="34" charset="0"/>
-                <a:ea typeface="Arial" pitchFamily="34" charset="-122"/>
-                <a:cs typeface="Arial" pitchFamily="34" charset="-120"/>
-              </a:rPr>
-              <a:t>Requirements (F-1–F-5)</a:t>
-            </a:r>
-            <a:endParaRPr lang="en-US" sz="1200" dirty="0"/>
-          </a:p>
-        </p:txBody>
-      </p:sp>
-      <p:sp>
-        <p:nvSpPr>
-          <p:cNvPr id="6" name="Text 4"/>
-          <p:cNvSpPr/>
-          <p:nvPr/>
-        </p:nvSpPr>
-        <p:spPr>
-          <a:xfrm>
-            <a:off x="6080760" y="1965960"/>
-            <a:ext cx="5669280" cy="3840480"/>
+                <a:latin typeface="Calibri" pitchFamily="34" charset="0"/>
+                <a:ea typeface="Calibri" pitchFamily="34" charset="-122"/>
+                <a:cs typeface="Calibri" pitchFamily="34" charset="-120"/>
+              </a:rPr>
+              <a:t>REQUIREMENTS (F-1–F-5)</a:t>
+            </a:r>
+            <a:endParaRPr lang="en-US" sz="1000" dirty="0"/>
+          </a:p>
+        </p:txBody>
+      </p:sp>
+      <p:sp>
+        <p:nvSpPr>
+          <p:cNvPr id="7" name="Text 5"/>
+          <p:cNvSpPr/>
+          <p:nvPr/>
+        </p:nvSpPr>
+        <p:spPr>
+          <a:xfrm>
+            <a:off x="5623560" y="1792224"/>
+            <a:ext cx="6080760" cy="4069080"/>
           </a:xfrm>
           <a:prstGeom prst="rect">
             <a:avLst/>
@@ -2279,17 +2460,17 @@
               <a:buChar char="•"/>
             </a:pPr>
             <a:r>
-              <a:rPr lang="en-US" sz="1400" dirty="0">
-                <a:solidFill>
-                  <a:srgbClr val="5C5C5C"/>
-                </a:solidFill>
-                <a:latin typeface="Arial" pitchFamily="34" charset="0"/>
-                <a:ea typeface="Arial" pitchFamily="34" charset="-122"/>
-                <a:cs typeface="Arial" pitchFamily="34" charset="-120"/>
+              <a:rPr lang="en-US" sz="1300" dirty="0">
+                <a:solidFill>
+                  <a:srgbClr val="6A6A6A"/>
+                </a:solidFill>
+                <a:latin typeface="Calibri" pitchFamily="34" charset="0"/>
+                <a:ea typeface="Calibri" pitchFamily="34" charset="-122"/>
+                <a:cs typeface="Calibri" pitchFamily="34" charset="-120"/>
               </a:rPr>
               <a:t>F-1 Accounts: signup, login, logout, protected routes.</a:t>
             </a:r>
-            <a:endParaRPr lang="en-US" sz="1400" dirty="0"/>
+            <a:endParaRPr lang="en-US" sz="1300" dirty="0"/>
           </a:p>
           <a:p>
             <a:pPr marL="342900" indent="-342900">
@@ -2297,17 +2478,17 @@
               <a:buChar char="•"/>
             </a:pPr>
             <a:r>
-              <a:rPr lang="en-US" sz="1400" dirty="0">
-                <a:solidFill>
-                  <a:srgbClr val="5C5C5C"/>
-                </a:solidFill>
-                <a:latin typeface="Arial" pitchFamily="34" charset="0"/>
-                <a:ea typeface="Arial" pitchFamily="34" charset="-122"/>
-                <a:cs typeface="Arial" pitchFamily="34" charset="-120"/>
+              <a:rPr lang="en-US" sz="1300" dirty="0">
+                <a:solidFill>
+                  <a:srgbClr val="6A6A6A"/>
+                </a:solidFill>
+                <a:latin typeface="Calibri" pitchFamily="34" charset="0"/>
+                <a:ea typeface="Calibri" pitchFamily="34" charset="-122"/>
+                <a:cs typeface="Calibri" pitchFamily="34" charset="-120"/>
               </a:rPr>
               <a:t>F-2 Wardrobe: uploads, CRUD, search, filters.</a:t>
             </a:r>
-            <a:endParaRPr lang="en-US" sz="1400" dirty="0"/>
+            <a:endParaRPr lang="en-US" sz="1300" dirty="0"/>
           </a:p>
           <a:p>
             <a:pPr marL="342900" indent="-342900">
@@ -2315,17 +2496,17 @@
               <a:buChar char="•"/>
             </a:pPr>
             <a:r>
-              <a:rPr lang="en-US" sz="1400" dirty="0">
-                <a:solidFill>
-                  <a:srgbClr val="5C5C5C"/>
-                </a:solidFill>
-                <a:latin typeface="Arial" pitchFamily="34" charset="0"/>
-                <a:ea typeface="Arial" pitchFamily="34" charset="-122"/>
-                <a:cs typeface="Arial" pitchFamily="34" charset="-120"/>
+              <a:rPr lang="en-US" sz="1300" dirty="0">
+                <a:solidFill>
+                  <a:srgbClr val="6A6A6A"/>
+                </a:solidFill>
+                <a:latin typeface="Calibri" pitchFamily="34" charset="0"/>
+                <a:ea typeface="Calibri" pitchFamily="34" charset="-122"/>
+                <a:cs typeface="Calibri" pitchFamily="34" charset="-120"/>
               </a:rPr>
               <a:t>F-3 Outfits: generate from saved items with explanations; rule-based engine in product, with optional LLM support described in the SRS.</a:t>
             </a:r>
-            <a:endParaRPr lang="en-US" sz="1400" dirty="0"/>
+            <a:endParaRPr lang="en-US" sz="1300" dirty="0"/>
           </a:p>
           <a:p>
             <a:pPr marL="342900" indent="-342900">
@@ -2333,17 +2514,17 @@
               <a:buChar char="•"/>
             </a:pPr>
             <a:r>
-              <a:rPr lang="en-US" sz="1400" dirty="0">
-                <a:solidFill>
-                  <a:srgbClr val="5C5C5C"/>
-                </a:solidFill>
-                <a:latin typeface="Arial" pitchFamily="34" charset="0"/>
-                <a:ea typeface="Arial" pitchFamily="34" charset="-122"/>
-                <a:cs typeface="Arial" pitchFamily="34" charset="-120"/>
+              <a:rPr lang="en-US" sz="1300" dirty="0">
+                <a:solidFill>
+                  <a:srgbClr val="6A6A6A"/>
+                </a:solidFill>
+                <a:latin typeface="Calibri" pitchFamily="34" charset="0"/>
+                <a:ea typeface="Calibri" pitchFamily="34" charset="-122"/>
+                <a:cs typeface="Calibri" pitchFamily="34" charset="-120"/>
               </a:rPr>
               <a:t>F-4 Outfit management: save, view, and manage favourite looks so users can build a library of go-to combinations.</a:t>
             </a:r>
-            <a:endParaRPr lang="en-US" sz="1400" dirty="0"/>
+            <a:endParaRPr lang="en-US" sz="1300" dirty="0"/>
           </a:p>
           <a:p>
             <a:pPr marL="342900" indent="-342900">
@@ -2351,17 +2532,17 @@
               <a:buChar char="•"/>
             </a:pPr>
             <a:r>
-              <a:rPr lang="en-US" sz="1400" dirty="0">
-                <a:solidFill>
-                  <a:srgbClr val="5C5C5C"/>
-                </a:solidFill>
-                <a:latin typeface="Arial" pitchFamily="34" charset="0"/>
-                <a:ea typeface="Arial" pitchFamily="34" charset="-122"/>
-                <a:cs typeface="Arial" pitchFamily="34" charset="-120"/>
+              <a:rPr lang="en-US" sz="1300" dirty="0">
+                <a:solidFill>
+                  <a:srgbClr val="6A6A6A"/>
+                </a:solidFill>
+                <a:latin typeface="Calibri" pitchFamily="34" charset="0"/>
+                <a:ea typeface="Calibri" pitchFamily="34" charset="-122"/>
+                <a:cs typeface="Calibri" pitchFamily="34" charset="-120"/>
               </a:rPr>
               <a:t>F-5 Context-aware generation: occasion plus richer signals (e.g. weather) to tighten recommendations when users want more precision.</a:t>
             </a:r>
-            <a:endParaRPr lang="en-US" sz="1400" dirty="0"/>
+            <a:endParaRPr lang="en-US" sz="1300" dirty="0"/>
           </a:p>
         </p:txBody>
       </p:sp>
@@ -2405,8 +2586,8 @@
         </p:nvSpPr>
         <p:spPr>
           <a:xfrm>
-            <a:off x="457200" y="411480"/>
-            <a:ext cx="3657600" cy="320040"/>
+            <a:off x="502920" y="347472"/>
+            <a:ext cx="3657600" cy="256032"/>
           </a:xfrm>
           <a:prstGeom prst="rect">
             <a:avLst/>
@@ -2422,17 +2603,17 @@
               <a:buNone/>
             </a:pPr>
             <a:r>
-              <a:rPr lang="en-US" sz="1100" dirty="0">
-                <a:solidFill>
-                  <a:srgbClr val="5C5C5C"/>
-                </a:solidFill>
-                <a:latin typeface="Arial" pitchFamily="34" charset="0"/>
-                <a:ea typeface="Arial" pitchFamily="34" charset="-122"/>
-                <a:cs typeface="Arial" pitchFamily="34" charset="-120"/>
-              </a:rPr>
-              <a:t>Product</a:t>
-            </a:r>
-            <a:endParaRPr lang="en-US" sz="1100" dirty="0"/>
+              <a:rPr lang="en-US" sz="1000" dirty="0">
+                <a:solidFill>
+                  <a:srgbClr val="6A6A6A"/>
+                </a:solidFill>
+                <a:latin typeface="Calibri" pitchFamily="34" charset="0"/>
+                <a:ea typeface="Calibri" pitchFamily="34" charset="-122"/>
+                <a:cs typeface="Calibri" pitchFamily="34" charset="-120"/>
+              </a:rPr>
+              <a:t>PRODUCT</a:t>
+            </a:r>
+            <a:endParaRPr lang="en-US" sz="1000" dirty="0"/>
           </a:p>
         </p:txBody>
       </p:sp>
@@ -2444,8 +2625,8 @@
         </p:nvSpPr>
         <p:spPr>
           <a:xfrm>
-            <a:off x="457200" y="685800"/>
-            <a:ext cx="10972800" cy="731520"/>
+            <a:off x="502920" y="566928"/>
+            <a:ext cx="11292840" cy="658368"/>
           </a:xfrm>
           <a:prstGeom prst="rect">
             <a:avLst/>
@@ -2461,30 +2642,80 @@
               <a:buNone/>
             </a:pPr>
             <a:r>
-              <a:rPr lang="en-US" sz="3200" b="1" dirty="0">
+              <a:rPr lang="en-US" sz="3400" b="1" dirty="0">
                 <a:solidFill>
                   <a:srgbClr val="0A0A0A"/>
                 </a:solidFill>
-                <a:latin typeface="Arial" pitchFamily="34" charset="0"/>
-                <a:ea typeface="Arial" pitchFamily="34" charset="-122"/>
-                <a:cs typeface="Arial" pitchFamily="34" charset="-120"/>
+                <a:latin typeface="Georgia" pitchFamily="34" charset="0"/>
+                <a:ea typeface="Georgia" pitchFamily="34" charset="-122"/>
+                <a:cs typeface="Georgia" pitchFamily="34" charset="-120"/>
               </a:rPr>
               <a:t>Main features</a:t>
             </a:r>
-            <a:endParaRPr lang="en-US" sz="3200" dirty="0"/>
-          </a:p>
-        </p:txBody>
-      </p:sp>
-      <p:sp>
-        <p:nvSpPr>
-          <p:cNvPr id="4" name="Text 2"/>
-          <p:cNvSpPr/>
-          <p:nvPr/>
-        </p:nvSpPr>
-        <p:spPr>
-          <a:xfrm>
-            <a:off x="502920" y="1600200"/>
-            <a:ext cx="3749040" cy="274320"/>
+            <a:endParaRPr lang="en-US" sz="3400" dirty="0"/>
+          </a:p>
+        </p:txBody>
+      </p:sp>
+      <p:sp>
+        <p:nvSpPr>
+          <p:cNvPr id="4" name="Shape 2"/>
+          <p:cNvSpPr/>
+          <p:nvPr/>
+        </p:nvSpPr>
+        <p:spPr>
+          <a:xfrm>
+            <a:off x="502920" y="1261872"/>
+            <a:ext cx="11292840" cy="0"/>
+          </a:xfrm>
+          <a:prstGeom prst="line">
+            <a:avLst/>
+          </a:prstGeom>
+          <a:noFill/>
+          <a:ln w="12700">
+            <a:solidFill>
+              <a:srgbClr val="E6E6E6"/>
+            </a:solidFill>
+            <a:prstDash val="solid"/>
+          </a:ln>
+        </p:spPr>
+      </p:sp>
+      <p:sp>
+        <p:nvSpPr>
+          <p:cNvPr id="5" name="Shape 3"/>
+          <p:cNvSpPr/>
+          <p:nvPr/>
+        </p:nvSpPr>
+        <p:spPr>
+          <a:xfrm>
+            <a:off x="457200" y="1399032"/>
+            <a:ext cx="3703320" cy="3246120"/>
+          </a:xfrm>
+          <a:prstGeom prst="roundRect">
+            <a:avLst>
+              <a:gd name="adj" fmla="val 3380"/>
+            </a:avLst>
+          </a:prstGeom>
+          <a:solidFill>
+            <a:srgbClr val="FFFFFF"/>
+          </a:solidFill>
+          <a:ln w="12700">
+            <a:solidFill>
+              <a:srgbClr val="E6E6E6"/>
+            </a:solidFill>
+            <a:prstDash val="solid"/>
+          </a:ln>
+        </p:spPr>
+      </p:sp>
+      <p:sp>
+        <p:nvSpPr>
+          <p:cNvPr id="6" name="Text 4"/>
+          <p:cNvSpPr/>
+          <p:nvPr/>
+        </p:nvSpPr>
+        <p:spPr>
+          <a:xfrm>
+            <a:off x="704088" y="1572768"/>
+            <a:ext cx="3209544" cy="256032"/>
           </a:xfrm>
           <a:prstGeom prst="rect">
             <a:avLst/>
@@ -2500,30 +2731,30 @@
               <a:buNone/>
             </a:pPr>
             <a:r>
-              <a:rPr lang="en-US" sz="1100" b="1" dirty="0">
+              <a:rPr lang="en-US" sz="1000" b="1" dirty="0">
                 <a:solidFill>
                   <a:srgbClr val="1A1B3A"/>
                 </a:solidFill>
-                <a:latin typeface="Arial" pitchFamily="34" charset="0"/>
-                <a:ea typeface="Arial" pitchFamily="34" charset="-122"/>
-                <a:cs typeface="Arial" pitchFamily="34" charset="-120"/>
+                <a:latin typeface="Calibri" pitchFamily="34" charset="0"/>
+                <a:ea typeface="Calibri" pitchFamily="34" charset="-122"/>
+                <a:cs typeface="Calibri" pitchFamily="34" charset="-120"/>
               </a:rPr>
               <a:t>F-1</a:t>
             </a:r>
-            <a:endParaRPr lang="en-US" sz="1100" dirty="0"/>
-          </a:p>
-        </p:txBody>
-      </p:sp>
-      <p:sp>
-        <p:nvSpPr>
-          <p:cNvPr id="5" name="Text 3"/>
-          <p:cNvSpPr/>
-          <p:nvPr/>
-        </p:nvSpPr>
-        <p:spPr>
-          <a:xfrm>
-            <a:off x="502920" y="1874520"/>
-            <a:ext cx="3749040" cy="502920"/>
+            <a:endParaRPr lang="en-US" sz="1000" dirty="0"/>
+          </a:p>
+        </p:txBody>
+      </p:sp>
+      <p:sp>
+        <p:nvSpPr>
+          <p:cNvPr id="7" name="Text 5"/>
+          <p:cNvSpPr/>
+          <p:nvPr/>
+        </p:nvSpPr>
+        <p:spPr>
+          <a:xfrm>
+            <a:off x="704088" y="1828800"/>
+            <a:ext cx="3209544" cy="438912"/>
           </a:xfrm>
           <a:prstGeom prst="rect">
             <a:avLst/>
@@ -2543,9 +2774,9 @@
                 <a:solidFill>
                   <a:srgbClr val="0A0A0A"/>
                 </a:solidFill>
-                <a:latin typeface="Arial" pitchFamily="34" charset="0"/>
-                <a:ea typeface="Arial" pitchFamily="34" charset="-122"/>
-                <a:cs typeface="Arial" pitchFamily="34" charset="-120"/>
+                <a:latin typeface="Georgia" pitchFamily="34" charset="0"/>
+                <a:ea typeface="Georgia" pitchFamily="34" charset="-122"/>
+                <a:cs typeface="Georgia" pitchFamily="34" charset="-120"/>
               </a:rPr>
               <a:t>Accounts</a:t>
             </a:r>
@@ -2555,14 +2786,14 @@
       </p:sp>
       <p:sp>
         <p:nvSpPr>
-          <p:cNvPr id="6" name="Text 4"/>
-          <p:cNvSpPr/>
-          <p:nvPr/>
-        </p:nvSpPr>
-        <p:spPr>
-          <a:xfrm>
-            <a:off x="502920" y="2423160"/>
-            <a:ext cx="3749040" cy="2560320"/>
+          <p:cNvPr id="8" name="Text 6"/>
+          <p:cNvSpPr/>
+          <p:nvPr/>
+        </p:nvSpPr>
+        <p:spPr>
+          <a:xfrm>
+            <a:off x="704088" y="2313432"/>
+            <a:ext cx="3209544" cy="2148840"/>
           </a:xfrm>
           <a:prstGeom prst="rect">
             <a:avLst/>
@@ -2578,30 +2809,57 @@
               <a:buNone/>
             </a:pPr>
             <a:r>
-              <a:rPr lang="en-US" sz="1500" dirty="0">
-                <a:solidFill>
-                  <a:srgbClr val="5C5C5C"/>
-                </a:solidFill>
-                <a:latin typeface="Arial" pitchFamily="34" charset="0"/>
-                <a:ea typeface="Arial" pitchFamily="34" charset="-122"/>
-                <a:cs typeface="Arial" pitchFamily="34" charset="-120"/>
+              <a:rPr lang="en-US" sz="1400" dirty="0">
+                <a:solidFill>
+                  <a:srgbClr val="6A6A6A"/>
+                </a:solidFill>
+                <a:latin typeface="Calibri" pitchFamily="34" charset="0"/>
+                <a:ea typeface="Calibri" pitchFamily="34" charset="-122"/>
+                <a:cs typeface="Calibri" pitchFamily="34" charset="-120"/>
               </a:rPr>
               <a:t>Private wardrobe per user: auth before any data, aligned with the SRS landing-to-dashboard flow.</a:t>
             </a:r>
-            <a:endParaRPr lang="en-US" sz="1500" dirty="0"/>
-          </a:p>
-        </p:txBody>
-      </p:sp>
-      <p:sp>
-        <p:nvSpPr>
-          <p:cNvPr id="7" name="Text 5"/>
-          <p:cNvSpPr/>
-          <p:nvPr/>
-        </p:nvSpPr>
-        <p:spPr>
-          <a:xfrm>
-            <a:off x="4480560" y="1600200"/>
-            <a:ext cx="3749040" cy="274320"/>
+            <a:endParaRPr lang="en-US" sz="1400" dirty="0"/>
+          </a:p>
+        </p:txBody>
+      </p:sp>
+      <p:sp>
+        <p:nvSpPr>
+          <p:cNvPr id="9" name="Shape 7"/>
+          <p:cNvSpPr/>
+          <p:nvPr/>
+        </p:nvSpPr>
+        <p:spPr>
+          <a:xfrm>
+            <a:off x="4270248" y="1399032"/>
+            <a:ext cx="3703320" cy="3246120"/>
+          </a:xfrm>
+          <a:prstGeom prst="roundRect">
+            <a:avLst>
+              <a:gd name="adj" fmla="val 3380"/>
+            </a:avLst>
+          </a:prstGeom>
+          <a:solidFill>
+            <a:srgbClr val="FFFFFF"/>
+          </a:solidFill>
+          <a:ln w="12700">
+            <a:solidFill>
+              <a:srgbClr val="E6E6E6"/>
+            </a:solidFill>
+            <a:prstDash val="solid"/>
+          </a:ln>
+        </p:spPr>
+      </p:sp>
+      <p:sp>
+        <p:nvSpPr>
+          <p:cNvPr id="10" name="Text 8"/>
+          <p:cNvSpPr/>
+          <p:nvPr/>
+        </p:nvSpPr>
+        <p:spPr>
+          <a:xfrm>
+            <a:off x="4517136" y="1572768"/>
+            <a:ext cx="3209544" cy="256032"/>
           </a:xfrm>
           <a:prstGeom prst="rect">
             <a:avLst/>
@@ -2617,30 +2875,30 @@
               <a:buNone/>
             </a:pPr>
             <a:r>
-              <a:rPr lang="en-US" sz="1100" b="1" dirty="0">
+              <a:rPr lang="en-US" sz="1000" b="1" dirty="0">
                 <a:solidFill>
                   <a:srgbClr val="1A1B3A"/>
                 </a:solidFill>
-                <a:latin typeface="Arial" pitchFamily="34" charset="0"/>
-                <a:ea typeface="Arial" pitchFamily="34" charset="-122"/>
-                <a:cs typeface="Arial" pitchFamily="34" charset="-120"/>
+                <a:latin typeface="Calibri" pitchFamily="34" charset="0"/>
+                <a:ea typeface="Calibri" pitchFamily="34" charset="-122"/>
+                <a:cs typeface="Calibri" pitchFamily="34" charset="-120"/>
               </a:rPr>
               <a:t>F-2</a:t>
             </a:r>
-            <a:endParaRPr lang="en-US" sz="1100" dirty="0"/>
-          </a:p>
-        </p:txBody>
-      </p:sp>
-      <p:sp>
-        <p:nvSpPr>
-          <p:cNvPr id="8" name="Text 6"/>
-          <p:cNvSpPr/>
-          <p:nvPr/>
-        </p:nvSpPr>
-        <p:spPr>
-          <a:xfrm>
-            <a:off x="4480560" y="1874520"/>
-            <a:ext cx="3749040" cy="502920"/>
+            <a:endParaRPr lang="en-US" sz="1000" dirty="0"/>
+          </a:p>
+        </p:txBody>
+      </p:sp>
+      <p:sp>
+        <p:nvSpPr>
+          <p:cNvPr id="11" name="Text 9"/>
+          <p:cNvSpPr/>
+          <p:nvPr/>
+        </p:nvSpPr>
+        <p:spPr>
+          <a:xfrm>
+            <a:off x="4517136" y="1828800"/>
+            <a:ext cx="3209544" cy="438912"/>
           </a:xfrm>
           <a:prstGeom prst="rect">
             <a:avLst/>
@@ -2660,9 +2918,9 @@
                 <a:solidFill>
                   <a:srgbClr val="0A0A0A"/>
                 </a:solidFill>
-                <a:latin typeface="Arial" pitchFamily="34" charset="0"/>
-                <a:ea typeface="Arial" pitchFamily="34" charset="-122"/>
-                <a:cs typeface="Arial" pitchFamily="34" charset="-120"/>
+                <a:latin typeface="Georgia" pitchFamily="34" charset="0"/>
+                <a:ea typeface="Georgia" pitchFamily="34" charset="-122"/>
+                <a:cs typeface="Georgia" pitchFamily="34" charset="-120"/>
               </a:rPr>
               <a:t>Wardrobe</a:t>
             </a:r>
@@ -2672,14 +2930,14 @@
       </p:sp>
       <p:sp>
         <p:nvSpPr>
-          <p:cNvPr id="9" name="Text 7"/>
-          <p:cNvSpPr/>
-          <p:nvPr/>
-        </p:nvSpPr>
-        <p:spPr>
-          <a:xfrm>
-            <a:off x="4480560" y="2423160"/>
-            <a:ext cx="3749040" cy="2560320"/>
+          <p:cNvPr id="12" name="Text 10"/>
+          <p:cNvSpPr/>
+          <p:nvPr/>
+        </p:nvSpPr>
+        <p:spPr>
+          <a:xfrm>
+            <a:off x="4517136" y="2313432"/>
+            <a:ext cx="3209544" cy="2148840"/>
           </a:xfrm>
           <a:prstGeom prst="rect">
             <a:avLst/>
@@ -2695,30 +2953,57 @@
               <a:buNone/>
             </a:pPr>
             <a:r>
-              <a:rPr lang="en-US" sz="1500" dirty="0">
-                <a:solidFill>
-                  <a:srgbClr val="5C5C5C"/>
-                </a:solidFill>
-                <a:latin typeface="Arial" pitchFamily="34" charset="0"/>
-                <a:ea typeface="Arial" pitchFamily="34" charset="-122"/>
-                <a:cs typeface="Arial" pitchFamily="34" charset="-120"/>
+              <a:rPr lang="en-US" sz="1400" dirty="0">
+                <a:solidFill>
+                  <a:srgbClr val="6A6A6A"/>
+                </a:solidFill>
+                <a:latin typeface="Calibri" pitchFamily="34" charset="0"/>
+                <a:ea typeface="Calibri" pitchFamily="34" charset="-122"/>
+                <a:cs typeface="Calibri" pitchFamily="34" charset="-120"/>
               </a:rPr>
               <a:t>Image-first intake, CRUD, search/filters, data that survives restarts.</a:t>
             </a:r>
-            <a:endParaRPr lang="en-US" sz="1500" dirty="0"/>
-          </a:p>
-        </p:txBody>
-      </p:sp>
-      <p:sp>
-        <p:nvSpPr>
-          <p:cNvPr id="10" name="Text 8"/>
-          <p:cNvSpPr/>
-          <p:nvPr/>
-        </p:nvSpPr>
-        <p:spPr>
-          <a:xfrm>
-            <a:off x="8458200" y="1600200"/>
-            <a:ext cx="3749040" cy="274320"/>
+            <a:endParaRPr lang="en-US" sz="1400" dirty="0"/>
+          </a:p>
+        </p:txBody>
+      </p:sp>
+      <p:sp>
+        <p:nvSpPr>
+          <p:cNvPr id="13" name="Shape 11"/>
+          <p:cNvSpPr/>
+          <p:nvPr/>
+        </p:nvSpPr>
+        <p:spPr>
+          <a:xfrm>
+            <a:off x="8083296" y="1399032"/>
+            <a:ext cx="3703320" cy="3246120"/>
+          </a:xfrm>
+          <a:prstGeom prst="roundRect">
+            <a:avLst>
+              <a:gd name="adj" fmla="val 3380"/>
+            </a:avLst>
+          </a:prstGeom>
+          <a:solidFill>
+            <a:srgbClr val="FFFFFF"/>
+          </a:solidFill>
+          <a:ln w="12700">
+            <a:solidFill>
+              <a:srgbClr val="E6E6E6"/>
+            </a:solidFill>
+            <a:prstDash val="solid"/>
+          </a:ln>
+        </p:spPr>
+      </p:sp>
+      <p:sp>
+        <p:nvSpPr>
+          <p:cNvPr id="14" name="Text 12"/>
+          <p:cNvSpPr/>
+          <p:nvPr/>
+        </p:nvSpPr>
+        <p:spPr>
+          <a:xfrm>
+            <a:off x="8330184" y="1572768"/>
+            <a:ext cx="3209544" cy="256032"/>
           </a:xfrm>
           <a:prstGeom prst="rect">
             <a:avLst/>
@@ -2734,30 +3019,30 @@
               <a:buNone/>
             </a:pPr>
             <a:r>
-              <a:rPr lang="en-US" sz="1100" b="1" dirty="0">
+              <a:rPr lang="en-US" sz="1000" b="1" dirty="0">
                 <a:solidFill>
                   <a:srgbClr val="1A1B3A"/>
                 </a:solidFill>
-                <a:latin typeface="Arial" pitchFamily="34" charset="0"/>
-                <a:ea typeface="Arial" pitchFamily="34" charset="-122"/>
-                <a:cs typeface="Arial" pitchFamily="34" charset="-120"/>
+                <a:latin typeface="Calibri" pitchFamily="34" charset="0"/>
+                <a:ea typeface="Calibri" pitchFamily="34" charset="-122"/>
+                <a:cs typeface="Calibri" pitchFamily="34" charset="-120"/>
               </a:rPr>
               <a:t>F-3</a:t>
             </a:r>
-            <a:endParaRPr lang="en-US" sz="1100" dirty="0"/>
-          </a:p>
-        </p:txBody>
-      </p:sp>
-      <p:sp>
-        <p:nvSpPr>
-          <p:cNvPr id="11" name="Text 9"/>
-          <p:cNvSpPr/>
-          <p:nvPr/>
-        </p:nvSpPr>
-        <p:spPr>
-          <a:xfrm>
-            <a:off x="8458200" y="1874520"/>
-            <a:ext cx="3749040" cy="502920"/>
+            <a:endParaRPr lang="en-US" sz="1000" dirty="0"/>
+          </a:p>
+        </p:txBody>
+      </p:sp>
+      <p:sp>
+        <p:nvSpPr>
+          <p:cNvPr id="15" name="Text 13"/>
+          <p:cNvSpPr/>
+          <p:nvPr/>
+        </p:nvSpPr>
+        <p:spPr>
+          <a:xfrm>
+            <a:off x="8330184" y="1828800"/>
+            <a:ext cx="3209544" cy="438912"/>
           </a:xfrm>
           <a:prstGeom prst="rect">
             <a:avLst/>
@@ -2777,9 +3062,9 @@
                 <a:solidFill>
                   <a:srgbClr val="0A0A0A"/>
                 </a:solidFill>
-                <a:latin typeface="Arial" pitchFamily="34" charset="0"/>
-                <a:ea typeface="Arial" pitchFamily="34" charset="-122"/>
-                <a:cs typeface="Arial" pitchFamily="34" charset="-120"/>
+                <a:latin typeface="Georgia" pitchFamily="34" charset="0"/>
+                <a:ea typeface="Georgia" pitchFamily="34" charset="-122"/>
+                <a:cs typeface="Georgia" pitchFamily="34" charset="-120"/>
               </a:rPr>
               <a:t>Outfits</a:t>
             </a:r>
@@ -2789,14 +3074,14 @@
       </p:sp>
       <p:sp>
         <p:nvSpPr>
-          <p:cNvPr id="12" name="Text 10"/>
-          <p:cNvSpPr/>
-          <p:nvPr/>
-        </p:nvSpPr>
-        <p:spPr>
-          <a:xfrm>
-            <a:off x="8458200" y="2423160"/>
-            <a:ext cx="3749040" cy="2560320"/>
+          <p:cNvPr id="16" name="Text 14"/>
+          <p:cNvSpPr/>
+          <p:nvPr/>
+        </p:nvSpPr>
+        <p:spPr>
+          <a:xfrm>
+            <a:off x="8330184" y="2313432"/>
+            <a:ext cx="3209544" cy="2148840"/>
           </a:xfrm>
           <a:prstGeom prst="rect">
             <a:avLst/>
@@ -2812,39 +3097,39 @@
               <a:buNone/>
             </a:pPr>
             <a:r>
-              <a:rPr lang="en-US" sz="1500" dirty="0">
-                <a:solidFill>
-                  <a:srgbClr val="5C5C5C"/>
-                </a:solidFill>
-                <a:latin typeface="Arial" pitchFamily="34" charset="0"/>
-                <a:ea typeface="Arial" pitchFamily="34" charset="-122"/>
-                <a:cs typeface="Arial" pitchFamily="34" charset="-120"/>
+              <a:rPr lang="en-US" sz="1400" dirty="0">
+                <a:solidFill>
+                  <a:srgbClr val="6A6A6A"/>
+                </a:solidFill>
+                <a:latin typeface="Calibri" pitchFamily="34" charset="0"/>
+                <a:ea typeface="Calibri" pitchFamily="34" charset="-122"/>
+                <a:cs typeface="Calibri" pitchFamily="34" charset="-120"/>
               </a:rPr>
               <a:t>Occasion + vibe in; outfits from your closet out, with rationale and regenerate.</a:t>
             </a:r>
-            <a:endParaRPr lang="en-US" sz="1500" dirty="0"/>
-          </a:p>
-        </p:txBody>
-      </p:sp>
-      <p:sp>
-        <p:nvSpPr>
-          <p:cNvPr id="13" name="Text 11"/>
-          <p:cNvSpPr/>
-          <p:nvPr/>
-        </p:nvSpPr>
-        <p:spPr>
-          <a:xfrm>
-            <a:off x="502920" y="5349240"/>
-            <a:ext cx="11247120" cy="822960"/>
-          </a:xfrm>
-          <a:prstGeom prst="rect">
-            <a:avLst/>
-          </a:prstGeom>
-          <a:noFill/>
-          <a:ln/>
-        </p:spPr>
-        <p:txBody>
-          <a:bodyPr wrap="square" rtlCol="0" anchor="ctr"/>
+            <a:endParaRPr lang="en-US" sz="1400" dirty="0"/>
+          </a:p>
+        </p:txBody>
+      </p:sp>
+      <p:sp>
+        <p:nvSpPr>
+          <p:cNvPr id="17" name="Text 15"/>
+          <p:cNvSpPr/>
+          <p:nvPr/>
+        </p:nvSpPr>
+        <p:spPr>
+          <a:xfrm>
+            <a:off x="502920" y="4919472"/>
+            <a:ext cx="11292840" cy="777240"/>
+          </a:xfrm>
+          <a:prstGeom prst="rect">
+            <a:avLst/>
+          </a:prstGeom>
+          <a:noFill/>
+          <a:ln/>
+        </p:spPr>
+        <p:txBody>
+          <a:bodyPr wrap="square" rtlCol="0" anchor="t"/>
           <a:lstStyle/>
           <a:p>
             <a:pPr indent="0" marL="0">
@@ -2853,11 +3138,11 @@
             <a:r>
               <a:rPr lang="en-US" sz="1300" dirty="0">
                 <a:solidFill>
-                  <a:srgbClr val="5C5C5C"/>
-                </a:solidFill>
-                <a:latin typeface="Arial" pitchFamily="34" charset="0"/>
-                <a:ea typeface="Arial" pitchFamily="34" charset="-122"/>
-                <a:cs typeface="Arial" pitchFamily="34" charset="-120"/>
+                  <a:srgbClr val="6A6A6A"/>
+                </a:solidFill>
+                <a:latin typeface="Calibri" pitchFamily="34" charset="0"/>
+                <a:ea typeface="Calibri" pitchFamily="34" charset="-122"/>
+                <a:cs typeface="Calibri" pitchFamily="34" charset="-120"/>
               </a:rPr>
               <a:t>F-4 favourites and F-5 richer context (e.g. weather) complete the SRS picture and extend the same dashboard-first experience.</a:t>
             </a:r>
@@ -2905,8 +3190,8 @@
         </p:nvSpPr>
         <p:spPr>
           <a:xfrm>
-            <a:off x="457200" y="411480"/>
-            <a:ext cx="3657600" cy="320040"/>
+            <a:off x="502920" y="347472"/>
+            <a:ext cx="3657600" cy="256032"/>
           </a:xfrm>
           <a:prstGeom prst="rect">
             <a:avLst/>
@@ -2922,17 +3207,17 @@
               <a:buNone/>
             </a:pPr>
             <a:r>
-              <a:rPr lang="en-US" sz="1100" dirty="0">
-                <a:solidFill>
-                  <a:srgbClr val="5C5C5C"/>
-                </a:solidFill>
-                <a:latin typeface="Arial" pitchFamily="34" charset="0"/>
-                <a:ea typeface="Arial" pitchFamily="34" charset="-122"/>
-                <a:cs typeface="Arial" pitchFamily="34" charset="-120"/>
-              </a:rPr>
-              <a:t>Stack</a:t>
-            </a:r>
-            <a:endParaRPr lang="en-US" sz="1100" dirty="0"/>
+              <a:rPr lang="en-US" sz="1000" dirty="0">
+                <a:solidFill>
+                  <a:srgbClr val="6A6A6A"/>
+                </a:solidFill>
+                <a:latin typeface="Calibri" pitchFamily="34" charset="0"/>
+                <a:ea typeface="Calibri" pitchFamily="34" charset="-122"/>
+                <a:cs typeface="Calibri" pitchFamily="34" charset="-120"/>
+              </a:rPr>
+              <a:t>STACK</a:t>
+            </a:r>
+            <a:endParaRPr lang="en-US" sz="1000" dirty="0"/>
           </a:p>
         </p:txBody>
       </p:sp>
@@ -2944,8 +3229,8 @@
         </p:nvSpPr>
         <p:spPr>
           <a:xfrm>
-            <a:off x="457200" y="685800"/>
-            <a:ext cx="10972800" cy="731520"/>
+            <a:off x="502920" y="566928"/>
+            <a:ext cx="11292840" cy="658368"/>
           </a:xfrm>
           <a:prstGeom prst="rect">
             <a:avLst/>
@@ -2961,30 +3246,80 @@
               <a:buNone/>
             </a:pPr>
             <a:r>
-              <a:rPr lang="en-US" sz="3200" b="1" dirty="0">
+              <a:rPr lang="en-US" sz="3400" b="1" dirty="0">
                 <a:solidFill>
                   <a:srgbClr val="0A0A0A"/>
                 </a:solidFill>
-                <a:latin typeface="Arial" pitchFamily="34" charset="0"/>
-                <a:ea typeface="Arial" pitchFamily="34" charset="-122"/>
-                <a:cs typeface="Arial" pitchFamily="34" charset="-120"/>
+                <a:latin typeface="Georgia" pitchFamily="34" charset="0"/>
+                <a:ea typeface="Georgia" pitchFamily="34" charset="-122"/>
+                <a:cs typeface="Georgia" pitchFamily="34" charset="-120"/>
               </a:rPr>
               <a:t>Structure &amp; tech</a:t>
             </a:r>
-            <a:endParaRPr lang="en-US" sz="3200" dirty="0"/>
-          </a:p>
-        </p:txBody>
-      </p:sp>
-      <p:sp>
-        <p:nvSpPr>
-          <p:cNvPr id="4" name="Text 2"/>
-          <p:cNvSpPr/>
-          <p:nvPr/>
-        </p:nvSpPr>
-        <p:spPr>
-          <a:xfrm>
-            <a:off x="502920" y="1554480"/>
-            <a:ext cx="3611880" cy="320040"/>
+            <a:endParaRPr lang="en-US" sz="3400" dirty="0"/>
+          </a:p>
+        </p:txBody>
+      </p:sp>
+      <p:sp>
+        <p:nvSpPr>
+          <p:cNvPr id="4" name="Shape 2"/>
+          <p:cNvSpPr/>
+          <p:nvPr/>
+        </p:nvSpPr>
+        <p:spPr>
+          <a:xfrm>
+            <a:off x="502920" y="1261872"/>
+            <a:ext cx="11292840" cy="0"/>
+          </a:xfrm>
+          <a:prstGeom prst="line">
+            <a:avLst/>
+          </a:prstGeom>
+          <a:noFill/>
+          <a:ln w="12700">
+            <a:solidFill>
+              <a:srgbClr val="E6E6E6"/>
+            </a:solidFill>
+            <a:prstDash val="solid"/>
+          </a:ln>
+        </p:spPr>
+      </p:sp>
+      <p:sp>
+        <p:nvSpPr>
+          <p:cNvPr id="5" name="Shape 3"/>
+          <p:cNvSpPr/>
+          <p:nvPr/>
+        </p:nvSpPr>
+        <p:spPr>
+          <a:xfrm>
+            <a:off x="457200" y="1399032"/>
+            <a:ext cx="3675888" cy="2697480"/>
+          </a:xfrm>
+          <a:prstGeom prst="roundRect">
+            <a:avLst>
+              <a:gd name="adj" fmla="val 4068"/>
+            </a:avLst>
+          </a:prstGeom>
+          <a:solidFill>
+            <a:srgbClr val="FFFFFF"/>
+          </a:solidFill>
+          <a:ln w="12700">
+            <a:solidFill>
+              <a:srgbClr val="E6E6E6"/>
+            </a:solidFill>
+            <a:prstDash val="solid"/>
+          </a:ln>
+        </p:spPr>
+      </p:sp>
+      <p:sp>
+        <p:nvSpPr>
+          <p:cNvPr id="6" name="Text 4"/>
+          <p:cNvSpPr/>
+          <p:nvPr/>
+        </p:nvSpPr>
+        <p:spPr>
+          <a:xfrm>
+            <a:off x="685800" y="1572768"/>
+            <a:ext cx="3218688" cy="274320"/>
           </a:xfrm>
           <a:prstGeom prst="rect">
             <a:avLst/>
@@ -3000,341 +3335,395 @@
               <a:buNone/>
             </a:pPr>
             <a:r>
+              <a:rPr lang="en-US" sz="900" dirty="0">
+                <a:solidFill>
+                  <a:srgbClr val="6A6A6A"/>
+                </a:solidFill>
+                <a:latin typeface="Calibri" pitchFamily="34" charset="0"/>
+                <a:ea typeface="Calibri" pitchFamily="34" charset="-122"/>
+                <a:cs typeface="Calibri" pitchFamily="34" charset="-120"/>
+              </a:rPr>
+              <a:t>CLIENT</a:t>
+            </a:r>
+            <a:endParaRPr lang="en-US" sz="900" dirty="0"/>
+          </a:p>
+        </p:txBody>
+      </p:sp>
+      <p:sp>
+        <p:nvSpPr>
+          <p:cNvPr id="7" name="Text 5"/>
+          <p:cNvSpPr/>
+          <p:nvPr/>
+        </p:nvSpPr>
+        <p:spPr>
+          <a:xfrm>
+            <a:off x="685800" y="1883664"/>
+            <a:ext cx="3218688" cy="2103120"/>
+          </a:xfrm>
+          <a:prstGeom prst="rect">
+            <a:avLst/>
+          </a:prstGeom>
+          <a:noFill/>
+          <a:ln/>
+        </p:spPr>
+        <p:txBody>
+          <a:bodyPr wrap="square" rtlCol="0" anchor="t"/>
+          <a:lstStyle/>
+          <a:p>
+            <a:pPr indent="0" marL="0">
+              <a:buNone/>
+            </a:pPr>
+            <a:r>
+              <a:rPr lang="en-US" sz="1400" dirty="0">
+                <a:solidFill>
+                  <a:srgbClr val="6A6A6A"/>
+                </a:solidFill>
+                <a:latin typeface="Calibri" pitchFamily="34" charset="0"/>
+                <a:ea typeface="Calibri" pitchFamily="34" charset="-122"/>
+                <a:cs typeface="Calibri" pitchFamily="34" charset="-120"/>
+              </a:rPr>
+              <a:t>React, React Router, JS, global CSS</a:t>
+            </a:r>
+            <a:endParaRPr lang="en-US" sz="1400" dirty="0"/>
+          </a:p>
+          <a:p>
+            <a:pPr indent="0" marL="0">
+              <a:buNone/>
+            </a:pPr>
+            <a:r>
+              <a:rPr lang="en-US" sz="1400" dirty="0">
+                <a:solidFill>
+                  <a:srgbClr val="6A6A6A"/>
+                </a:solidFill>
+                <a:latin typeface="Calibri" pitchFamily="34" charset="0"/>
+                <a:ea typeface="Calibri" pitchFamily="34" charset="-122"/>
+                <a:cs typeface="Calibri" pitchFamily="34" charset="-120"/>
+              </a:rPr>
+              <a:t>Dev proxy (setupProxy)</a:t>
+            </a:r>
+            <a:endParaRPr lang="en-US" sz="1400" dirty="0"/>
+          </a:p>
+        </p:txBody>
+      </p:sp>
+      <p:sp>
+        <p:nvSpPr>
+          <p:cNvPr id="8" name="Shape 6"/>
+          <p:cNvSpPr/>
+          <p:nvPr/>
+        </p:nvSpPr>
+        <p:spPr>
+          <a:xfrm>
+            <a:off x="4224528" y="1399032"/>
+            <a:ext cx="3675888" cy="2697480"/>
+          </a:xfrm>
+          <a:prstGeom prst="roundRect">
+            <a:avLst>
+              <a:gd name="adj" fmla="val 4068"/>
+            </a:avLst>
+          </a:prstGeom>
+          <a:solidFill>
+            <a:srgbClr val="FFFFFF"/>
+          </a:solidFill>
+          <a:ln w="12700">
+            <a:solidFill>
+              <a:srgbClr val="E6E6E6"/>
+            </a:solidFill>
+            <a:prstDash val="solid"/>
+          </a:ln>
+        </p:spPr>
+      </p:sp>
+      <p:sp>
+        <p:nvSpPr>
+          <p:cNvPr id="9" name="Text 7"/>
+          <p:cNvSpPr/>
+          <p:nvPr/>
+        </p:nvSpPr>
+        <p:spPr>
+          <a:xfrm>
+            <a:off x="4453128" y="1572768"/>
+            <a:ext cx="3218688" cy="274320"/>
+          </a:xfrm>
+          <a:prstGeom prst="rect">
+            <a:avLst/>
+          </a:prstGeom>
+          <a:noFill/>
+          <a:ln/>
+        </p:spPr>
+        <p:txBody>
+          <a:bodyPr wrap="square" rtlCol="0" anchor="ctr"/>
+          <a:lstStyle/>
+          <a:p>
+            <a:pPr indent="0" marL="0">
+              <a:buNone/>
+            </a:pPr>
+            <a:r>
+              <a:rPr lang="en-US" sz="900" dirty="0">
+                <a:solidFill>
+                  <a:srgbClr val="6A6A6A"/>
+                </a:solidFill>
+                <a:latin typeface="Calibri" pitchFamily="34" charset="0"/>
+                <a:ea typeface="Calibri" pitchFamily="34" charset="-122"/>
+                <a:cs typeface="Calibri" pitchFamily="34" charset="-120"/>
+              </a:rPr>
+              <a:t>SERVER</a:t>
+            </a:r>
+            <a:endParaRPr lang="en-US" sz="900" dirty="0"/>
+          </a:p>
+        </p:txBody>
+      </p:sp>
+      <p:sp>
+        <p:nvSpPr>
+          <p:cNvPr id="10" name="Text 8"/>
+          <p:cNvSpPr/>
+          <p:nvPr/>
+        </p:nvSpPr>
+        <p:spPr>
+          <a:xfrm>
+            <a:off x="4453128" y="1883664"/>
+            <a:ext cx="3218688" cy="2103120"/>
+          </a:xfrm>
+          <a:prstGeom prst="rect">
+            <a:avLst/>
+          </a:prstGeom>
+          <a:noFill/>
+          <a:ln/>
+        </p:spPr>
+        <p:txBody>
+          <a:bodyPr wrap="square" rtlCol="0" anchor="t"/>
+          <a:lstStyle/>
+          <a:p>
+            <a:pPr indent="0" marL="0">
+              <a:buNone/>
+            </a:pPr>
+            <a:r>
+              <a:rPr lang="en-US" sz="1400" dirty="0">
+                <a:solidFill>
+                  <a:srgbClr val="6A6A6A"/>
+                </a:solidFill>
+                <a:latin typeface="Calibri" pitchFamily="34" charset="0"/>
+                <a:ea typeface="Calibri" pitchFamily="34" charset="-122"/>
+                <a:cs typeface="Calibri" pitchFamily="34" charset="-120"/>
+              </a:rPr>
+              <a:t>Express, session auth</a:t>
+            </a:r>
+            <a:endParaRPr lang="en-US" sz="1400" dirty="0"/>
+          </a:p>
+          <a:p>
+            <a:pPr indent="0" marL="0">
+              <a:buNone/>
+            </a:pPr>
+            <a:r>
+              <a:rPr lang="en-US" sz="1400" dirty="0">
+                <a:solidFill>
+                  <a:srgbClr val="6A6A6A"/>
+                </a:solidFill>
+                <a:latin typeface="Calibri" pitchFamily="34" charset="0"/>
+                <a:ea typeface="Calibri" pitchFamily="34" charset="-122"/>
+                <a:cs typeface="Calibri" pitchFamily="34" charset="-120"/>
+              </a:rPr>
+              <a:t>Multipart image uploads</a:t>
+            </a:r>
+            <a:endParaRPr lang="en-US" sz="1400" dirty="0"/>
+          </a:p>
+        </p:txBody>
+      </p:sp>
+      <p:sp>
+        <p:nvSpPr>
+          <p:cNvPr id="11" name="Shape 9"/>
+          <p:cNvSpPr/>
+          <p:nvPr/>
+        </p:nvSpPr>
+        <p:spPr>
+          <a:xfrm>
+            <a:off x="7991856" y="1399032"/>
+            <a:ext cx="3675888" cy="2697480"/>
+          </a:xfrm>
+          <a:prstGeom prst="roundRect">
+            <a:avLst>
+              <a:gd name="adj" fmla="val 4068"/>
+            </a:avLst>
+          </a:prstGeom>
+          <a:solidFill>
+            <a:srgbClr val="FFFFFF"/>
+          </a:solidFill>
+          <a:ln w="12700">
+            <a:solidFill>
+              <a:srgbClr val="E6E6E6"/>
+            </a:solidFill>
+            <a:prstDash val="solid"/>
+          </a:ln>
+        </p:spPr>
+      </p:sp>
+      <p:sp>
+        <p:nvSpPr>
+          <p:cNvPr id="12" name="Text 10"/>
+          <p:cNvSpPr/>
+          <p:nvPr/>
+        </p:nvSpPr>
+        <p:spPr>
+          <a:xfrm>
+            <a:off x="8220456" y="1572768"/>
+            <a:ext cx="3218688" cy="274320"/>
+          </a:xfrm>
+          <a:prstGeom prst="rect">
+            <a:avLst/>
+          </a:prstGeom>
+          <a:noFill/>
+          <a:ln/>
+        </p:spPr>
+        <p:txBody>
+          <a:bodyPr wrap="square" rtlCol="0" anchor="ctr"/>
+          <a:lstStyle/>
+          <a:p>
+            <a:pPr indent="0" marL="0">
+              <a:buNone/>
+            </a:pPr>
+            <a:r>
+              <a:rPr lang="en-US" sz="900" dirty="0">
+                <a:solidFill>
+                  <a:srgbClr val="6A6A6A"/>
+                </a:solidFill>
+                <a:latin typeface="Calibri" pitchFamily="34" charset="0"/>
+                <a:ea typeface="Calibri" pitchFamily="34" charset="-122"/>
+                <a:cs typeface="Calibri" pitchFamily="34" charset="-120"/>
+              </a:rPr>
+              <a:t>DATA</a:t>
+            </a:r>
+            <a:endParaRPr lang="en-US" sz="900" dirty="0"/>
+          </a:p>
+        </p:txBody>
+      </p:sp>
+      <p:sp>
+        <p:nvSpPr>
+          <p:cNvPr id="13" name="Text 11"/>
+          <p:cNvSpPr/>
+          <p:nvPr/>
+        </p:nvSpPr>
+        <p:spPr>
+          <a:xfrm>
+            <a:off x="8220456" y="1883664"/>
+            <a:ext cx="3218688" cy="2103120"/>
+          </a:xfrm>
+          <a:prstGeom prst="rect">
+            <a:avLst/>
+          </a:prstGeom>
+          <a:noFill/>
+          <a:ln/>
+        </p:spPr>
+        <p:txBody>
+          <a:bodyPr wrap="square" rtlCol="0" anchor="t"/>
+          <a:lstStyle/>
+          <a:p>
+            <a:pPr indent="0" marL="0">
+              <a:buNone/>
+            </a:pPr>
+            <a:r>
+              <a:rPr lang="en-US" sz="1400" dirty="0">
+                <a:solidFill>
+                  <a:srgbClr val="6A6A6A"/>
+                </a:solidFill>
+                <a:latin typeface="Calibri" pitchFamily="34" charset="0"/>
+                <a:ea typeface="Calibri" pitchFamily="34" charset="-122"/>
+                <a:cs typeface="Calibri" pitchFamily="34" charset="-120"/>
+              </a:rPr>
+              <a:t>sql.js / SQLite (backend/data/app.db)</a:t>
+            </a:r>
+            <a:endParaRPr lang="en-US" sz="1400" dirty="0"/>
+          </a:p>
+          <a:p>
+            <a:pPr indent="0" marL="0">
+              <a:buNone/>
+            </a:pPr>
+            <a:r>
+              <a:rPr lang="en-US" sz="1400" dirty="0">
+                <a:solidFill>
+                  <a:srgbClr val="6A6A6A"/>
+                </a:solidFill>
+                <a:latin typeface="Calibri" pitchFamily="34" charset="0"/>
+                <a:ea typeface="Calibri" pitchFamily="34" charset="-122"/>
+                <a:cs typeface="Calibri" pitchFamily="34" charset="-120"/>
+              </a:rPr>
+              <a:t>Local image storage alongside metadata</a:t>
+            </a:r>
+            <a:endParaRPr lang="en-US" sz="1400" dirty="0"/>
+          </a:p>
+        </p:txBody>
+      </p:sp>
+      <p:sp>
+        <p:nvSpPr>
+          <p:cNvPr id="14" name="Text 12"/>
+          <p:cNvSpPr/>
+          <p:nvPr/>
+        </p:nvSpPr>
+        <p:spPr>
+          <a:xfrm>
+            <a:off x="502920" y="4306824"/>
+            <a:ext cx="11292840" cy="960120"/>
+          </a:xfrm>
+          <a:prstGeom prst="rect">
+            <a:avLst/>
+          </a:prstGeom>
+          <a:noFill/>
+          <a:ln/>
+        </p:spPr>
+        <p:txBody>
+          <a:bodyPr wrap="square" rtlCol="0" anchor="t"/>
+          <a:lstStyle/>
+          <a:p>
+            <a:pPr indent="0" marL="0">
+              <a:buNone/>
+            </a:pPr>
+            <a:r>
+              <a:rPr lang="en-US" sz="1300" dirty="0">
+                <a:solidFill>
+                  <a:srgbClr val="6A6A6A"/>
+                </a:solidFill>
+                <a:latin typeface="Calibri" pitchFamily="34" charset="0"/>
+                <a:ea typeface="Calibri" pitchFamily="34" charset="-122"/>
+                <a:cs typeface="Calibri" pitchFamily="34" charset="-120"/>
+              </a:rPr>
+              <a:t>Outfit logic runs locally for fast, inspectable behavior; the SRS also describes optional LLM and contextual inputs alongside F-5. A4: feature branches, PRs, reviewed merges, clear commits.</a:t>
+            </a:r>
+            <a:endParaRPr lang="en-US" sz="1300" dirty="0"/>
+          </a:p>
+        </p:txBody>
+      </p:sp>
+      <p:sp>
+        <p:nvSpPr>
+          <p:cNvPr id="15" name="Text 13"/>
+          <p:cNvSpPr/>
+          <p:nvPr/>
+        </p:nvSpPr>
+        <p:spPr>
+          <a:xfrm>
+            <a:off x="502920" y="5330952"/>
+            <a:ext cx="11292840" cy="365760"/>
+          </a:xfrm>
+          <a:prstGeom prst="rect">
+            <a:avLst/>
+          </a:prstGeom>
+          <a:noFill/>
+          <a:ln/>
+        </p:spPr>
+        <p:txBody>
+          <a:bodyPr wrap="square" rtlCol="0" anchor="ctr"/>
+          <a:lstStyle/>
+          <a:p>
+            <a:pPr indent="0" marL="0">
+              <a:buNone/>
+            </a:pPr>
+            <a:r>
               <a:rPr lang="en-US" sz="1000" dirty="0">
                 <a:solidFill>
-                  <a:srgbClr val="5C5C5C"/>
-                </a:solidFill>
-                <a:latin typeface="Arial" pitchFamily="34" charset="0"/>
-                <a:ea typeface="Arial" pitchFamily="34" charset="-122"/>
-                <a:cs typeface="Arial" pitchFamily="34" charset="-120"/>
-              </a:rPr>
-              <a:t>CLIENT</a:t>
+                  <a:srgbClr val="6A6A6A"/>
+                </a:solidFill>
+                <a:latin typeface="Calibri" pitchFamily="34" charset="0"/>
+                <a:ea typeface="Calibri" pitchFamily="34" charset="-122"/>
+                <a:cs typeface="Calibri" pitchFamily="34" charset="-120"/>
+              </a:rPr>
+              <a:t>React     ·     Express     ·     SQLite     ·     Sessions     ·     Git / PRs</a:t>
             </a:r>
             <a:endParaRPr lang="en-US" sz="1000" dirty="0"/>
-          </a:p>
-        </p:txBody>
-      </p:sp>
-      <p:sp>
-        <p:nvSpPr>
-          <p:cNvPr id="5" name="Text 3"/>
-          <p:cNvSpPr/>
-          <p:nvPr/>
-        </p:nvSpPr>
-        <p:spPr>
-          <a:xfrm>
-            <a:off x="502920" y="1874520"/>
-            <a:ext cx="3611880" cy="2286000"/>
-          </a:xfrm>
-          <a:prstGeom prst="rect">
-            <a:avLst/>
-          </a:prstGeom>
-          <a:noFill/>
-          <a:ln/>
-        </p:spPr>
-        <p:txBody>
-          <a:bodyPr wrap="square" rtlCol="0" anchor="t"/>
-          <a:lstStyle/>
-          <a:p>
-            <a:pPr indent="0" marL="0">
-              <a:buNone/>
-            </a:pPr>
-            <a:r>
-              <a:rPr lang="en-US" sz="1500" dirty="0">
-                <a:solidFill>
-                  <a:srgbClr val="5C5C5C"/>
-                </a:solidFill>
-                <a:latin typeface="Arial" pitchFamily="34" charset="0"/>
-                <a:ea typeface="Arial" pitchFamily="34" charset="-122"/>
-                <a:cs typeface="Arial" pitchFamily="34" charset="-120"/>
-              </a:rPr>
-              <a:t>React, React Router, JS, global CSS</a:t>
-            </a:r>
-            <a:endParaRPr lang="en-US" sz="1500" dirty="0"/>
-          </a:p>
-          <a:p>
-            <a:pPr indent="0" marL="0">
-              <a:buNone/>
-            </a:pPr>
-            <a:r>
-              <a:rPr lang="en-US" sz="1500" dirty="0">
-                <a:solidFill>
-                  <a:srgbClr val="5C5C5C"/>
-                </a:solidFill>
-                <a:latin typeface="Arial" pitchFamily="34" charset="0"/>
-                <a:ea typeface="Arial" pitchFamily="34" charset="-122"/>
-                <a:cs typeface="Arial" pitchFamily="34" charset="-120"/>
-              </a:rPr>
-              <a:t>Dev proxy (setupProxy)</a:t>
-            </a:r>
-            <a:endParaRPr lang="en-US" sz="1500" dirty="0"/>
-          </a:p>
-        </p:txBody>
-      </p:sp>
-      <p:sp>
-        <p:nvSpPr>
-          <p:cNvPr id="6" name="Text 4"/>
-          <p:cNvSpPr/>
-          <p:nvPr/>
-        </p:nvSpPr>
-        <p:spPr>
-          <a:xfrm>
-            <a:off x="4297680" y="1554480"/>
-            <a:ext cx="3611880" cy="320040"/>
-          </a:xfrm>
-          <a:prstGeom prst="rect">
-            <a:avLst/>
-          </a:prstGeom>
-          <a:noFill/>
-          <a:ln/>
-        </p:spPr>
-        <p:txBody>
-          <a:bodyPr wrap="square" rtlCol="0" anchor="ctr"/>
-          <a:lstStyle/>
-          <a:p>
-            <a:pPr indent="0" marL="0">
-              <a:buNone/>
-            </a:pPr>
-            <a:r>
-              <a:rPr lang="en-US" sz="1000" dirty="0">
-                <a:solidFill>
-                  <a:srgbClr val="5C5C5C"/>
-                </a:solidFill>
-                <a:latin typeface="Arial" pitchFamily="34" charset="0"/>
-                <a:ea typeface="Arial" pitchFamily="34" charset="-122"/>
-                <a:cs typeface="Arial" pitchFamily="34" charset="-120"/>
-              </a:rPr>
-              <a:t>SERVER</a:t>
-            </a:r>
-            <a:endParaRPr lang="en-US" sz="1000" dirty="0"/>
-          </a:p>
-        </p:txBody>
-      </p:sp>
-      <p:sp>
-        <p:nvSpPr>
-          <p:cNvPr id="7" name="Text 5"/>
-          <p:cNvSpPr/>
-          <p:nvPr/>
-        </p:nvSpPr>
-        <p:spPr>
-          <a:xfrm>
-            <a:off x="4297680" y="1874520"/>
-            <a:ext cx="3611880" cy="2286000"/>
-          </a:xfrm>
-          <a:prstGeom prst="rect">
-            <a:avLst/>
-          </a:prstGeom>
-          <a:noFill/>
-          <a:ln/>
-        </p:spPr>
-        <p:txBody>
-          <a:bodyPr wrap="square" rtlCol="0" anchor="t"/>
-          <a:lstStyle/>
-          <a:p>
-            <a:pPr indent="0" marL="0">
-              <a:buNone/>
-            </a:pPr>
-            <a:r>
-              <a:rPr lang="en-US" sz="1500" dirty="0">
-                <a:solidFill>
-                  <a:srgbClr val="5C5C5C"/>
-                </a:solidFill>
-                <a:latin typeface="Arial" pitchFamily="34" charset="0"/>
-                <a:ea typeface="Arial" pitchFamily="34" charset="-122"/>
-                <a:cs typeface="Arial" pitchFamily="34" charset="-120"/>
-              </a:rPr>
-              <a:t>Express, session auth</a:t>
-            </a:r>
-            <a:endParaRPr lang="en-US" sz="1500" dirty="0"/>
-          </a:p>
-          <a:p>
-            <a:pPr indent="0" marL="0">
-              <a:buNone/>
-            </a:pPr>
-            <a:r>
-              <a:rPr lang="en-US" sz="1500" dirty="0">
-                <a:solidFill>
-                  <a:srgbClr val="5C5C5C"/>
-                </a:solidFill>
-                <a:latin typeface="Arial" pitchFamily="34" charset="0"/>
-                <a:ea typeface="Arial" pitchFamily="34" charset="-122"/>
-                <a:cs typeface="Arial" pitchFamily="34" charset="-120"/>
-              </a:rPr>
-              <a:t>Multipart image uploads</a:t>
-            </a:r>
-            <a:endParaRPr lang="en-US" sz="1500" dirty="0"/>
-          </a:p>
-        </p:txBody>
-      </p:sp>
-      <p:sp>
-        <p:nvSpPr>
-          <p:cNvPr id="8" name="Text 6"/>
-          <p:cNvSpPr/>
-          <p:nvPr/>
-        </p:nvSpPr>
-        <p:spPr>
-          <a:xfrm>
-            <a:off x="8092440" y="1554480"/>
-            <a:ext cx="3611880" cy="320040"/>
-          </a:xfrm>
-          <a:prstGeom prst="rect">
-            <a:avLst/>
-          </a:prstGeom>
-          <a:noFill/>
-          <a:ln/>
-        </p:spPr>
-        <p:txBody>
-          <a:bodyPr wrap="square" rtlCol="0" anchor="ctr"/>
-          <a:lstStyle/>
-          <a:p>
-            <a:pPr indent="0" marL="0">
-              <a:buNone/>
-            </a:pPr>
-            <a:r>
-              <a:rPr lang="en-US" sz="1000" dirty="0">
-                <a:solidFill>
-                  <a:srgbClr val="5C5C5C"/>
-                </a:solidFill>
-                <a:latin typeface="Arial" pitchFamily="34" charset="0"/>
-                <a:ea typeface="Arial" pitchFamily="34" charset="-122"/>
-                <a:cs typeface="Arial" pitchFamily="34" charset="-120"/>
-              </a:rPr>
-              <a:t>DATA</a:t>
-            </a:r>
-            <a:endParaRPr lang="en-US" sz="1000" dirty="0"/>
-          </a:p>
-        </p:txBody>
-      </p:sp>
-      <p:sp>
-        <p:nvSpPr>
-          <p:cNvPr id="9" name="Text 7"/>
-          <p:cNvSpPr/>
-          <p:nvPr/>
-        </p:nvSpPr>
-        <p:spPr>
-          <a:xfrm>
-            <a:off x="8092440" y="1874520"/>
-            <a:ext cx="3611880" cy="2286000"/>
-          </a:xfrm>
-          <a:prstGeom prst="rect">
-            <a:avLst/>
-          </a:prstGeom>
-          <a:noFill/>
-          <a:ln/>
-        </p:spPr>
-        <p:txBody>
-          <a:bodyPr wrap="square" rtlCol="0" anchor="t"/>
-          <a:lstStyle/>
-          <a:p>
-            <a:pPr indent="0" marL="0">
-              <a:buNone/>
-            </a:pPr>
-            <a:r>
-              <a:rPr lang="en-US" sz="1500" dirty="0">
-                <a:solidFill>
-                  <a:srgbClr val="5C5C5C"/>
-                </a:solidFill>
-                <a:latin typeface="Arial" pitchFamily="34" charset="0"/>
-                <a:ea typeface="Arial" pitchFamily="34" charset="-122"/>
-                <a:cs typeface="Arial" pitchFamily="34" charset="-120"/>
-              </a:rPr>
-              <a:t>sql.js / SQLite (backend/data/app.db)</a:t>
-            </a:r>
-            <a:endParaRPr lang="en-US" sz="1500" dirty="0"/>
-          </a:p>
-          <a:p>
-            <a:pPr indent="0" marL="0">
-              <a:buNone/>
-            </a:pPr>
-            <a:r>
-              <a:rPr lang="en-US" sz="1500" dirty="0">
-                <a:solidFill>
-                  <a:srgbClr val="5C5C5C"/>
-                </a:solidFill>
-                <a:latin typeface="Arial" pitchFamily="34" charset="0"/>
-                <a:ea typeface="Arial" pitchFamily="34" charset="-122"/>
-                <a:cs typeface="Arial" pitchFamily="34" charset="-120"/>
-              </a:rPr>
-              <a:t>Local image storage alongside metadata</a:t>
-            </a:r>
-            <a:endParaRPr lang="en-US" sz="1500" dirty="0"/>
-          </a:p>
-        </p:txBody>
-      </p:sp>
-      <p:sp>
-        <p:nvSpPr>
-          <p:cNvPr id="10" name="Text 8"/>
-          <p:cNvSpPr/>
-          <p:nvPr/>
-        </p:nvSpPr>
-        <p:spPr>
-          <a:xfrm>
-            <a:off x="502920" y="4434840"/>
-            <a:ext cx="11247120" cy="1005840"/>
-          </a:xfrm>
-          <a:prstGeom prst="rect">
-            <a:avLst/>
-          </a:prstGeom>
-          <a:noFill/>
-          <a:ln/>
-        </p:spPr>
-        <p:txBody>
-          <a:bodyPr wrap="square" rtlCol="0" anchor="t"/>
-          <a:lstStyle/>
-          <a:p>
-            <a:pPr indent="0" marL="0">
-              <a:buNone/>
-            </a:pPr>
-            <a:r>
-              <a:rPr lang="en-US" sz="1300" dirty="0">
-                <a:solidFill>
-                  <a:srgbClr val="5C5C5C"/>
-                </a:solidFill>
-                <a:latin typeface="Arial" pitchFamily="34" charset="0"/>
-                <a:ea typeface="Arial" pitchFamily="34" charset="-122"/>
-                <a:cs typeface="Arial" pitchFamily="34" charset="-120"/>
-              </a:rPr>
-              <a:t>Outfit logic runs locally for fast, inspectable behavior; the SRS also describes optional LLM and contextual inputs alongside F-5. A4: feature branches, PRs, reviewed merges, clear commits.</a:t>
-            </a:r>
-            <a:endParaRPr lang="en-US" sz="1300" dirty="0"/>
-          </a:p>
-        </p:txBody>
-      </p:sp>
-      <p:sp>
-        <p:nvSpPr>
-          <p:cNvPr id="11" name="Text 9"/>
-          <p:cNvSpPr/>
-          <p:nvPr/>
-        </p:nvSpPr>
-        <p:spPr>
-          <a:xfrm>
-            <a:off x="502920" y="5623560"/>
-            <a:ext cx="11247120" cy="411480"/>
-          </a:xfrm>
-          <a:prstGeom prst="rect">
-            <a:avLst/>
-          </a:prstGeom>
-          <a:noFill/>
-          <a:ln/>
-        </p:spPr>
-        <p:txBody>
-          <a:bodyPr wrap="square" rtlCol="0" anchor="ctr"/>
-          <a:lstStyle/>
-          <a:p>
-            <a:pPr indent="0" marL="0">
-              <a:buNone/>
-            </a:pPr>
-            <a:r>
-              <a:rPr lang="en-US" sz="1100" dirty="0">
-                <a:solidFill>
-                  <a:srgbClr val="5C5C5C"/>
-                </a:solidFill>
-                <a:latin typeface="Arial" pitchFamily="34" charset="0"/>
-                <a:ea typeface="Arial" pitchFamily="34" charset="-122"/>
-                <a:cs typeface="Arial" pitchFamily="34" charset="-120"/>
-              </a:rPr>
-              <a:t>React   ·   Express   ·   SQLite   ·   Sessions   ·   Git / PRs</a:t>
-            </a:r>
-            <a:endParaRPr lang="en-US" sz="1100" dirty="0"/>
           </a:p>
         </p:txBody>
       </p:sp>
@@ -3378,8 +3767,8 @@
         </p:nvSpPr>
         <p:spPr>
           <a:xfrm>
-            <a:off x="457200" y="411480"/>
-            <a:ext cx="3657600" cy="320040"/>
+            <a:off x="502920" y="347472"/>
+            <a:ext cx="3657600" cy="256032"/>
           </a:xfrm>
           <a:prstGeom prst="rect">
             <a:avLst/>
@@ -3395,17 +3784,17 @@
               <a:buNone/>
             </a:pPr>
             <a:r>
-              <a:rPr lang="en-US" sz="1100" dirty="0">
-                <a:solidFill>
-                  <a:srgbClr val="5C5C5C"/>
-                </a:solidFill>
-                <a:latin typeface="Arial" pitchFamily="34" charset="0"/>
-                <a:ea typeface="Arial" pitchFamily="34" charset="-122"/>
-                <a:cs typeface="Arial" pitchFamily="34" charset="-120"/>
-              </a:rPr>
-              <a:t>Showcase</a:t>
-            </a:r>
-            <a:endParaRPr lang="en-US" sz="1100" dirty="0"/>
+              <a:rPr lang="en-US" sz="1000" dirty="0">
+                <a:solidFill>
+                  <a:srgbClr val="6A6A6A"/>
+                </a:solidFill>
+                <a:latin typeface="Calibri" pitchFamily="34" charset="0"/>
+                <a:ea typeface="Calibri" pitchFamily="34" charset="-122"/>
+                <a:cs typeface="Calibri" pitchFamily="34" charset="-120"/>
+              </a:rPr>
+              <a:t>SHOWCASE</a:t>
+            </a:r>
+            <a:endParaRPr lang="en-US" sz="1000" dirty="0"/>
           </a:p>
         </p:txBody>
       </p:sp>
@@ -3417,8 +3806,8 @@
         </p:nvSpPr>
         <p:spPr>
           <a:xfrm>
-            <a:off x="457200" y="685800"/>
-            <a:ext cx="10972800" cy="731520"/>
+            <a:off x="502920" y="566928"/>
+            <a:ext cx="11292840" cy="658368"/>
           </a:xfrm>
           <a:prstGeom prst="rect">
             <a:avLst/>
@@ -3434,56 +3823,106 @@
               <a:buNone/>
             </a:pPr>
             <a:r>
+              <a:rPr lang="en-US" sz="3400" b="1" dirty="0">
+                <a:solidFill>
+                  <a:srgbClr val="0A0A0A"/>
+                </a:solidFill>
+                <a:latin typeface="Georgia" pitchFamily="34" charset="0"/>
+                <a:ea typeface="Georgia" pitchFamily="34" charset="-122"/>
+                <a:cs typeface="Georgia" pitchFamily="34" charset="-120"/>
+              </a:rPr>
+              <a:t>Live demo</a:t>
+            </a:r>
+            <a:endParaRPr lang="en-US" sz="3400" dirty="0"/>
+          </a:p>
+        </p:txBody>
+      </p:sp>
+      <p:sp>
+        <p:nvSpPr>
+          <p:cNvPr id="4" name="Shape 2"/>
+          <p:cNvSpPr/>
+          <p:nvPr/>
+        </p:nvSpPr>
+        <p:spPr>
+          <a:xfrm>
+            <a:off x="502920" y="1261872"/>
+            <a:ext cx="11292840" cy="0"/>
+          </a:xfrm>
+          <a:prstGeom prst="line">
+            <a:avLst/>
+          </a:prstGeom>
+          <a:noFill/>
+          <a:ln w="12700">
+            <a:solidFill>
+              <a:srgbClr val="E6E6E6"/>
+            </a:solidFill>
+            <a:prstDash val="solid"/>
+          </a:ln>
+        </p:spPr>
+      </p:sp>
+      <p:sp>
+        <p:nvSpPr>
+          <p:cNvPr id="5" name="Shape 3"/>
+          <p:cNvSpPr/>
+          <p:nvPr/>
+        </p:nvSpPr>
+        <p:spPr>
+          <a:xfrm>
+            <a:off x="2346808" y="1764792"/>
+            <a:ext cx="7498080" cy="2606040"/>
+          </a:xfrm>
+          <a:prstGeom prst="roundRect">
+            <a:avLst>
+              <a:gd name="adj" fmla="val 5263"/>
+            </a:avLst>
+          </a:prstGeom>
+          <a:solidFill>
+            <a:srgbClr val="FFFFFF"/>
+          </a:solidFill>
+          <a:ln w="12700">
+            <a:solidFill>
+              <a:srgbClr val="E6E6E6"/>
+            </a:solidFill>
+            <a:prstDash val="dash"/>
+          </a:ln>
+        </p:spPr>
+      </p:sp>
+      <p:sp>
+        <p:nvSpPr>
+          <p:cNvPr id="6" name="Text 4"/>
+          <p:cNvSpPr/>
+          <p:nvPr/>
+        </p:nvSpPr>
+        <p:spPr>
+          <a:xfrm>
+            <a:off x="2346808" y="2633472"/>
+            <a:ext cx="7498080" cy="822960"/>
+          </a:xfrm>
+          <a:prstGeom prst="rect">
+            <a:avLst/>
+          </a:prstGeom>
+          <a:noFill/>
+          <a:ln/>
+        </p:spPr>
+        <p:txBody>
+          <a:bodyPr wrap="square" rtlCol="0" anchor="ctr"/>
+          <a:lstStyle/>
+          <a:p>
+            <a:pPr algn="ctr" indent="0" marL="0">
+              <a:buNone/>
+            </a:pPr>
+            <a:r>
               <a:rPr lang="en-US" sz="3200" b="1" dirty="0">
                 <a:solidFill>
                   <a:srgbClr val="0A0A0A"/>
                 </a:solidFill>
-                <a:latin typeface="Arial" pitchFamily="34" charset="0"/>
-                <a:ea typeface="Arial" pitchFamily="34" charset="-122"/>
-                <a:cs typeface="Arial" pitchFamily="34" charset="-120"/>
-              </a:rPr>
-              <a:t>Live demo</a:t>
+                <a:latin typeface="Georgia" pitchFamily="34" charset="0"/>
+                <a:ea typeface="Georgia" pitchFamily="34" charset="-122"/>
+                <a:cs typeface="Georgia" pitchFamily="34" charset="-120"/>
+              </a:rPr>
+              <a:t>ClosetAI: live walkthrough</a:t>
             </a:r>
             <a:endParaRPr lang="en-US" sz="3200" dirty="0"/>
-          </a:p>
-        </p:txBody>
-      </p:sp>
-      <p:sp>
-        <p:nvSpPr>
-          <p:cNvPr id="4" name="Text 2"/>
-          <p:cNvSpPr/>
-          <p:nvPr/>
-        </p:nvSpPr>
-        <p:spPr>
-          <a:xfrm>
-            <a:off x="1371600" y="2743200"/>
-            <a:ext cx="6400800" cy="914400"/>
-          </a:xfrm>
-          <a:prstGeom prst="rect">
-            <a:avLst/>
-          </a:prstGeom>
-          <a:noFill/>
-          <a:ln/>
-        </p:spPr>
-        <p:txBody>
-          <a:bodyPr wrap="square" rtlCol="0" anchor="ctr"/>
-          <a:lstStyle/>
-          <a:p>
-            <a:pPr algn="ctr" indent="0" marL="0">
-              <a:buNone/>
-            </a:pPr>
-            <a:r>
-              <a:rPr lang="en-US" sz="3600" b="1" dirty="0">
-                <a:solidFill>
-                  <a:srgbClr val="0A0A0A"/>
-                </a:solidFill>
-                <a:latin typeface="Arial" pitchFamily="34" charset="0"/>
-                <a:ea typeface="Arial" pitchFamily="34" charset="-122"/>
-                <a:cs typeface="Arial" pitchFamily="34" charset="-120"/>
-              </a:rPr>
-              <a:t>ClosetAI: live walkthrough</a:t>
-            </a:r>
-            <a:endParaRPr lang="en-US" sz="3600" dirty="0"/>
           </a:p>
         </p:txBody>
       </p:sp>
@@ -3527,8 +3966,8 @@
         </p:nvSpPr>
         <p:spPr>
           <a:xfrm>
-            <a:off x="457200" y="411480"/>
-            <a:ext cx="3657600" cy="320040"/>
+            <a:off x="502920" y="347472"/>
+            <a:ext cx="3657600" cy="256032"/>
           </a:xfrm>
           <a:prstGeom prst="rect">
             <a:avLst/>
@@ -3544,17 +3983,17 @@
               <a:buNone/>
             </a:pPr>
             <a:r>
-              <a:rPr lang="en-US" sz="1100" dirty="0">
-                <a:solidFill>
-                  <a:srgbClr val="5C5C5C"/>
-                </a:solidFill>
-                <a:latin typeface="Arial" pitchFamily="34" charset="0"/>
-                <a:ea typeface="Arial" pitchFamily="34" charset="-122"/>
-                <a:cs typeface="Arial" pitchFamily="34" charset="-120"/>
-              </a:rPr>
-              <a:t>Group 12</a:t>
-            </a:r>
-            <a:endParaRPr lang="en-US" sz="1100" dirty="0"/>
+              <a:rPr lang="en-US" sz="1000" dirty="0">
+                <a:solidFill>
+                  <a:srgbClr val="6A6A6A"/>
+                </a:solidFill>
+                <a:latin typeface="Calibri" pitchFamily="34" charset="0"/>
+                <a:ea typeface="Calibri" pitchFamily="34" charset="-122"/>
+                <a:cs typeface="Calibri" pitchFamily="34" charset="-120"/>
+              </a:rPr>
+              <a:t>GROUP 12</a:t>
+            </a:r>
+            <a:endParaRPr lang="en-US" sz="1000" dirty="0"/>
           </a:p>
         </p:txBody>
       </p:sp>
@@ -3566,8 +4005,8 @@
         </p:nvSpPr>
         <p:spPr>
           <a:xfrm>
-            <a:off x="457200" y="685800"/>
-            <a:ext cx="10972800" cy="731520"/>
+            <a:off x="502920" y="566928"/>
+            <a:ext cx="11292840" cy="658368"/>
           </a:xfrm>
           <a:prstGeom prst="rect">
             <a:avLst/>
@@ -3583,30 +4022,53 @@
               <a:buNone/>
             </a:pPr>
             <a:r>
-              <a:rPr lang="en-US" sz="3200" b="1" dirty="0">
+              <a:rPr lang="en-US" sz="3400" b="1" dirty="0">
                 <a:solidFill>
                   <a:srgbClr val="0A0A0A"/>
                 </a:solidFill>
-                <a:latin typeface="Arial" pitchFamily="34" charset="0"/>
-                <a:ea typeface="Arial" pitchFamily="34" charset="-122"/>
-                <a:cs typeface="Arial" pitchFamily="34" charset="-120"/>
+                <a:latin typeface="Georgia" pitchFamily="34" charset="0"/>
+                <a:ea typeface="Georgia" pitchFamily="34" charset="-122"/>
+                <a:cs typeface="Georgia" pitchFamily="34" charset="-120"/>
               </a:rPr>
               <a:t>Project management</a:t>
             </a:r>
-            <a:endParaRPr lang="en-US" sz="3200" dirty="0"/>
-          </a:p>
-        </p:txBody>
-      </p:sp>
-      <p:sp>
-        <p:nvSpPr>
-          <p:cNvPr id="4" name="Text 2"/>
-          <p:cNvSpPr/>
-          <p:nvPr/>
-        </p:nvSpPr>
-        <p:spPr>
-          <a:xfrm>
-            <a:off x="502920" y="1600200"/>
-            <a:ext cx="5394960" cy="365760"/>
+            <a:endParaRPr lang="en-US" sz="3400" dirty="0"/>
+          </a:p>
+        </p:txBody>
+      </p:sp>
+      <p:sp>
+        <p:nvSpPr>
+          <p:cNvPr id="4" name="Shape 2"/>
+          <p:cNvSpPr/>
+          <p:nvPr/>
+        </p:nvSpPr>
+        <p:spPr>
+          <a:xfrm>
+            <a:off x="502920" y="1261872"/>
+            <a:ext cx="11292840" cy="0"/>
+          </a:xfrm>
+          <a:prstGeom prst="line">
+            <a:avLst/>
+          </a:prstGeom>
+          <a:noFill/>
+          <a:ln w="12700">
+            <a:solidFill>
+              <a:srgbClr val="E6E6E6"/>
+            </a:solidFill>
+            <a:prstDash val="solid"/>
+          </a:ln>
+        </p:spPr>
+      </p:sp>
+      <p:sp>
+        <p:nvSpPr>
+          <p:cNvPr id="5" name="Text 3"/>
+          <p:cNvSpPr/>
+          <p:nvPr/>
+        </p:nvSpPr>
+        <p:spPr>
+          <a:xfrm>
+            <a:off x="502920" y="1444752"/>
+            <a:ext cx="5440680" cy="347472"/>
           </a:xfrm>
           <a:prstGeom prst="rect">
             <a:avLst/>
@@ -3622,30 +4084,30 @@
               <a:buNone/>
             </a:pPr>
             <a:r>
-              <a:rPr lang="en-US" sz="1800" b="1" dirty="0">
+              <a:rPr lang="en-US" sz="1900" b="1" dirty="0">
                 <a:solidFill>
                   <a:srgbClr val="0A0A0A"/>
                 </a:solidFill>
-                <a:latin typeface="Arial" pitchFamily="34" charset="0"/>
-                <a:ea typeface="Arial" pitchFamily="34" charset="-122"/>
-                <a:cs typeface="Arial" pitchFamily="34" charset="-120"/>
+                <a:latin typeface="Georgia" pitchFamily="34" charset="0"/>
+                <a:ea typeface="Georgia" pitchFamily="34" charset="-122"/>
+                <a:cs typeface="Georgia" pitchFamily="34" charset="-120"/>
               </a:rPr>
               <a:t>Challenges</a:t>
             </a:r>
-            <a:endParaRPr lang="en-US" sz="1800" dirty="0"/>
-          </a:p>
-        </p:txBody>
-      </p:sp>
-      <p:sp>
-        <p:nvSpPr>
-          <p:cNvPr id="5" name="Text 3"/>
-          <p:cNvSpPr/>
-          <p:nvPr/>
-        </p:nvSpPr>
-        <p:spPr>
-          <a:xfrm>
-            <a:off x="502920" y="2011680"/>
-            <a:ext cx="5394960" cy="1645920"/>
+            <a:endParaRPr lang="en-US" sz="1900" dirty="0"/>
+          </a:p>
+        </p:txBody>
+      </p:sp>
+      <p:sp>
+        <p:nvSpPr>
+          <p:cNvPr id="6" name="Text 4"/>
+          <p:cNvSpPr/>
+          <p:nvPr/>
+        </p:nvSpPr>
+        <p:spPr>
+          <a:xfrm>
+            <a:off x="502920" y="1828800"/>
+            <a:ext cx="5394960" cy="1783080"/>
           </a:xfrm>
           <a:prstGeom prst="rect">
             <a:avLst/>
@@ -3662,17 +4124,17 @@
               <a:buChar char="•"/>
             </a:pPr>
             <a:r>
-              <a:rPr lang="en-US" sz="1400" dirty="0">
-                <a:solidFill>
-                  <a:srgbClr val="5C5C5C"/>
-                </a:solidFill>
-                <a:latin typeface="Arial" pitchFamily="34" charset="0"/>
-                <a:ea typeface="Arial" pitchFamily="34" charset="-122"/>
-                <a:cs typeface="Arial" pitchFamily="34" charset="-120"/>
+              <a:rPr lang="en-US" sz="1300" dirty="0">
+                <a:solidFill>
+                  <a:srgbClr val="6A6A6A"/>
+                </a:solidFill>
+                <a:latin typeface="Calibri" pitchFamily="34" charset="0"/>
+                <a:ea typeface="Calibri" pitchFamily="34" charset="-122"/>
+                <a:cs typeface="Calibri" pitchFamily="34" charset="-120"/>
               </a:rPr>
               <a:t>Sequencing a full SRS: stable auth, wardrobe, and outfit flows first, then layering favourites and contextual generation without blocking the team.</a:t>
             </a:r>
-            <a:endParaRPr lang="en-US" sz="1400" dirty="0"/>
+            <a:endParaRPr lang="en-US" sz="1300" dirty="0"/>
           </a:p>
           <a:p>
             <a:pPr marL="342900" indent="-342900">
@@ -3680,17 +4142,17 @@
               <a:buChar char="•"/>
             </a:pPr>
             <a:r>
-              <a:rPr lang="en-US" sz="1400" dirty="0">
-                <a:solidFill>
-                  <a:srgbClr val="5C5C5C"/>
-                </a:solidFill>
-                <a:latin typeface="Arial" pitchFamily="34" charset="0"/>
-                <a:ea typeface="Arial" pitchFamily="34" charset="-122"/>
-                <a:cs typeface="Arial" pitchFamily="34" charset="-120"/>
+              <a:rPr lang="en-US" sz="1300" dirty="0">
+                <a:solidFill>
+                  <a:srgbClr val="6A6A6A"/>
+                </a:solidFill>
+                <a:latin typeface="Calibri" pitchFamily="34" charset="0"/>
+                <a:ea typeface="Calibri" pitchFamily="34" charset="-122"/>
+                <a:cs typeface="Calibri" pitchFamily="34" charset="-120"/>
               </a:rPr>
               <a:t>Full-stack glue: sessions, uploads, DB, proxy across laptops.</a:t>
             </a:r>
-            <a:endParaRPr lang="en-US" sz="1400" dirty="0"/>
+            <a:endParaRPr lang="en-US" sz="1300" dirty="0"/>
           </a:p>
           <a:p>
             <a:pPr marL="342900" indent="-342900">
@@ -3698,30 +4160,30 @@
               <a:buChar char="•"/>
             </a:pPr>
             <a:r>
-              <a:rPr lang="en-US" sz="1400" dirty="0">
-                <a:solidFill>
-                  <a:srgbClr val="5C5C5C"/>
-                </a:solidFill>
-                <a:latin typeface="Arial" pitchFamily="34" charset="0"/>
-                <a:ea typeface="Arial" pitchFamily="34" charset="-122"/>
-                <a:cs typeface="Arial" pitchFamily="34" charset="-120"/>
+              <a:rPr lang="en-US" sz="1300" dirty="0">
+                <a:solidFill>
+                  <a:srgbClr val="6A6A6A"/>
+                </a:solidFill>
+                <a:latin typeface="Calibri" pitchFamily="34" charset="0"/>
+                <a:ea typeface="Calibri" pitchFamily="34" charset="-122"/>
+                <a:cs typeface="Calibri" pitchFamily="34" charset="-120"/>
               </a:rPr>
               <a:t>Keeping acceptance criteria shared while work ran in parallel.</a:t>
             </a:r>
-            <a:endParaRPr lang="en-US" sz="1400" dirty="0"/>
-          </a:p>
-        </p:txBody>
-      </p:sp>
-      <p:sp>
-        <p:nvSpPr>
-          <p:cNvPr id="6" name="Text 4"/>
-          <p:cNvSpPr/>
-          <p:nvPr/>
-        </p:nvSpPr>
-        <p:spPr>
-          <a:xfrm>
-            <a:off x="502920" y="3886200"/>
-            <a:ext cx="5394960" cy="365760"/>
+            <a:endParaRPr lang="en-US" sz="1300" dirty="0"/>
+          </a:p>
+        </p:txBody>
+      </p:sp>
+      <p:sp>
+        <p:nvSpPr>
+          <p:cNvPr id="7" name="Text 5"/>
+          <p:cNvSpPr/>
+          <p:nvPr/>
+        </p:nvSpPr>
+        <p:spPr>
+          <a:xfrm>
+            <a:off x="502920" y="3767328"/>
+            <a:ext cx="5440680" cy="347472"/>
           </a:xfrm>
           <a:prstGeom prst="rect">
             <a:avLst/>
@@ -3737,30 +4199,30 @@
               <a:buNone/>
             </a:pPr>
             <a:r>
-              <a:rPr lang="en-US" sz="1800" b="1" dirty="0">
+              <a:rPr lang="en-US" sz="1900" b="1" dirty="0">
                 <a:solidFill>
                   <a:srgbClr val="0A0A0A"/>
                 </a:solidFill>
-                <a:latin typeface="Arial" pitchFamily="34" charset="0"/>
-                <a:ea typeface="Arial" pitchFamily="34" charset="-122"/>
-                <a:cs typeface="Arial" pitchFamily="34" charset="-120"/>
+                <a:latin typeface="Georgia" pitchFamily="34" charset="0"/>
+                <a:ea typeface="Georgia" pitchFamily="34" charset="-122"/>
+                <a:cs typeface="Georgia" pitchFamily="34" charset="-120"/>
               </a:rPr>
               <a:t>What we used from class</a:t>
             </a:r>
-            <a:endParaRPr lang="en-US" sz="1800" dirty="0"/>
-          </a:p>
-        </p:txBody>
-      </p:sp>
-      <p:sp>
-        <p:nvSpPr>
-          <p:cNvPr id="7" name="Text 5"/>
-          <p:cNvSpPr/>
-          <p:nvPr/>
-        </p:nvSpPr>
-        <p:spPr>
-          <a:xfrm>
-            <a:off x="502920" y="4297680"/>
-            <a:ext cx="5394960" cy="1645920"/>
+            <a:endParaRPr lang="en-US" sz="1900" dirty="0"/>
+          </a:p>
+        </p:txBody>
+      </p:sp>
+      <p:sp>
+        <p:nvSpPr>
+          <p:cNvPr id="8" name="Text 6"/>
+          <p:cNvSpPr/>
+          <p:nvPr/>
+        </p:nvSpPr>
+        <p:spPr>
+          <a:xfrm>
+            <a:off x="502920" y="4151376"/>
+            <a:ext cx="5394960" cy="1783080"/>
           </a:xfrm>
           <a:prstGeom prst="rect">
             <a:avLst/>
@@ -3777,17 +4239,17 @@
               <a:buChar char="•"/>
             </a:pPr>
             <a:r>
-              <a:rPr lang="en-US" sz="1400" dirty="0">
-                <a:solidFill>
-                  <a:srgbClr val="5C5C5C"/>
-                </a:solidFill>
-                <a:latin typeface="Arial" pitchFamily="34" charset="0"/>
-                <a:ea typeface="Arial" pitchFamily="34" charset="-122"/>
-                <a:cs typeface="Arial" pitchFamily="34" charset="-120"/>
+              <a:rPr lang="en-US" sz="1300" dirty="0">
+                <a:solidFill>
+                  <a:srgbClr val="6A6A6A"/>
+                </a:solidFill>
+                <a:latin typeface="Calibri" pitchFamily="34" charset="0"/>
+                <a:ea typeface="Calibri" pitchFamily="34" charset="-122"/>
+                <a:cs typeface="Calibri" pitchFamily="34" charset="-120"/>
               </a:rPr>
               <a:t>A2 WBS for packages and ownership.</a:t>
             </a:r>
-            <a:endParaRPr lang="en-US" sz="1400" dirty="0"/>
+            <a:endParaRPr lang="en-US" sz="1300" dirty="0"/>
           </a:p>
           <a:p>
             <a:pPr marL="342900" indent="-342900">
@@ -3795,17 +4257,17 @@
               <a:buChar char="•"/>
             </a:pPr>
             <a:r>
-              <a:rPr lang="en-US" sz="1400" dirty="0">
-                <a:solidFill>
-                  <a:srgbClr val="5C5C5C"/>
-                </a:solidFill>
-                <a:latin typeface="Arial" pitchFamily="34" charset="0"/>
-                <a:ea typeface="Arial" pitchFamily="34" charset="-122"/>
-                <a:cs typeface="Arial" pitchFamily="34" charset="-120"/>
+              <a:rPr lang="en-US" sz="1300" dirty="0">
+                <a:solidFill>
+                  <a:srgbClr val="6A6A6A"/>
+                </a:solidFill>
+                <a:latin typeface="Calibri" pitchFamily="34" charset="0"/>
+                <a:ea typeface="Calibri" pitchFamily="34" charset="-122"/>
+                <a:cs typeface="Calibri" pitchFamily="34" charset="-120"/>
               </a:rPr>
               <a:t>A3 schedule, dependencies, critical path.</a:t>
             </a:r>
-            <a:endParaRPr lang="en-US" sz="1400" dirty="0"/>
+            <a:endParaRPr lang="en-US" sz="1300" dirty="0"/>
           </a:p>
           <a:p>
             <a:pPr marL="342900" indent="-342900">
@@ -3813,15 +4275,93 @@
               <a:buChar char="•"/>
             </a:pPr>
             <a:r>
+              <a:rPr lang="en-US" sz="1300" dirty="0">
+                <a:solidFill>
+                  <a:srgbClr val="6A6A6A"/>
+                </a:solidFill>
+                <a:latin typeface="Calibri" pitchFamily="34" charset="0"/>
+                <a:ea typeface="Calibri" pitchFamily="34" charset="-122"/>
+                <a:cs typeface="Calibri" pitchFamily="34" charset="-120"/>
+              </a:rPr>
+              <a:t>A4 Git: branches, PRs, required reviews.</a:t>
+            </a:r>
+            <a:endParaRPr lang="en-US" sz="1300" dirty="0"/>
+          </a:p>
+        </p:txBody>
+      </p:sp>
+      <p:sp>
+        <p:nvSpPr>
+          <p:cNvPr id="9" name="Text 7"/>
+          <p:cNvSpPr/>
+          <p:nvPr/>
+        </p:nvSpPr>
+        <p:spPr>
+          <a:xfrm>
+            <a:off x="6263640" y="1444752"/>
+            <a:ext cx="5532120" cy="347472"/>
+          </a:xfrm>
+          <a:prstGeom prst="rect">
+            <a:avLst/>
+          </a:prstGeom>
+          <a:noFill/>
+          <a:ln/>
+        </p:spPr>
+        <p:txBody>
+          <a:bodyPr wrap="square" rtlCol="0" anchor="ctr"/>
+          <a:lstStyle/>
+          <a:p>
+            <a:pPr indent="0" marL="0">
+              <a:buNone/>
+            </a:pPr>
+            <a:r>
+              <a:rPr lang="en-US" sz="1900" b="1" dirty="0">
+                <a:solidFill>
+                  <a:srgbClr val="0A0A0A"/>
+                </a:solidFill>
+                <a:latin typeface="Georgia" pitchFamily="34" charset="0"/>
+                <a:ea typeface="Georgia" pitchFamily="34" charset="-122"/>
+                <a:cs typeface="Georgia" pitchFamily="34" charset="-120"/>
+              </a:rPr>
+              <a:t>Next time</a:t>
+            </a:r>
+            <a:endParaRPr lang="en-US" sz="1900" dirty="0"/>
+          </a:p>
+        </p:txBody>
+      </p:sp>
+      <p:sp>
+        <p:nvSpPr>
+          <p:cNvPr id="10" name="Text 8"/>
+          <p:cNvSpPr/>
+          <p:nvPr/>
+        </p:nvSpPr>
+        <p:spPr>
+          <a:xfrm>
+            <a:off x="6263640" y="1828800"/>
+            <a:ext cx="5532120" cy="1417320"/>
+          </a:xfrm>
+          <a:prstGeom prst="rect">
+            <a:avLst/>
+          </a:prstGeom>
+          <a:noFill/>
+          <a:ln/>
+        </p:spPr>
+        <p:txBody>
+          <a:bodyPr wrap="square" rtlCol="0" anchor="t"/>
+          <a:lstStyle/>
+          <a:p>
+            <a:pPr indent="0" marL="0">
+              <a:buNone/>
+            </a:pPr>
+            <a:r>
               <a:rPr lang="en-US" sz="1400" dirty="0">
                 <a:solidFill>
-                  <a:srgbClr val="5C5C5C"/>
-                </a:solidFill>
-                <a:latin typeface="Arial" pitchFamily="34" charset="0"/>
-                <a:ea typeface="Arial" pitchFamily="34" charset="-122"/>
-                <a:cs typeface="Arial" pitchFamily="34" charset="-120"/>
-              </a:rPr>
-              <a:t>A4 Git: branches, PRs, required reviews.</a:t>
+                  <a:srgbClr val="6A6A6A"/>
+                </a:solidFill>
+                <a:latin typeface="Calibri" pitchFamily="34" charset="0"/>
+                <a:ea typeface="Calibri" pitchFamily="34" charset="-122"/>
+                <a:cs typeface="Calibri" pitchFamily="34" charset="-120"/>
+              </a:rPr>
+              <a:t>Earlier shared API examples and short decision notes after scope discussions, so fewer surprises late in the term.</a:t>
             </a:r>
             <a:endParaRPr lang="en-US" sz="1400" dirty="0"/>
           </a:p>
@@ -3829,14 +4369,14 @@
       </p:sp>
       <p:sp>
         <p:nvSpPr>
-          <p:cNvPr id="8" name="Text 6"/>
-          <p:cNvSpPr/>
-          <p:nvPr/>
-        </p:nvSpPr>
-        <p:spPr>
-          <a:xfrm>
-            <a:off x="6080760" y="1600200"/>
-            <a:ext cx="5669280" cy="365760"/>
+          <p:cNvPr id="11" name="Text 9"/>
+          <p:cNvSpPr/>
+          <p:nvPr/>
+        </p:nvSpPr>
+        <p:spPr>
+          <a:xfrm>
+            <a:off x="6263640" y="3401568"/>
+            <a:ext cx="5532120" cy="347472"/>
           </a:xfrm>
           <a:prstGeom prst="rect">
             <a:avLst/>
@@ -3852,30 +4392,30 @@
               <a:buNone/>
             </a:pPr>
             <a:r>
-              <a:rPr lang="en-US" sz="1800" b="1" dirty="0">
+              <a:rPr lang="en-US" sz="1900" b="1" dirty="0">
                 <a:solidFill>
                   <a:srgbClr val="0A0A0A"/>
                 </a:solidFill>
-                <a:latin typeface="Arial" pitchFamily="34" charset="0"/>
-                <a:ea typeface="Arial" pitchFamily="34" charset="-122"/>
-                <a:cs typeface="Arial" pitchFamily="34" charset="-120"/>
-              </a:rPr>
-              <a:t>Next time</a:t>
-            </a:r>
-            <a:endParaRPr lang="en-US" sz="1800" dirty="0"/>
-          </a:p>
-        </p:txBody>
-      </p:sp>
-      <p:sp>
-        <p:nvSpPr>
-          <p:cNvPr id="9" name="Text 7"/>
-          <p:cNvSpPr/>
-          <p:nvPr/>
-        </p:nvSpPr>
-        <p:spPr>
-          <a:xfrm>
-            <a:off x="6080760" y="2011680"/>
-            <a:ext cx="5669280" cy="1371600"/>
+                <a:latin typeface="Georgia" pitchFamily="34" charset="0"/>
+                <a:ea typeface="Georgia" pitchFamily="34" charset="-122"/>
+                <a:cs typeface="Georgia" pitchFamily="34" charset="-120"/>
+              </a:rPr>
+              <a:t>Reviews</a:t>
+            </a:r>
+            <a:endParaRPr lang="en-US" sz="1900" dirty="0"/>
+          </a:p>
+        </p:txBody>
+      </p:sp>
+      <p:sp>
+        <p:nvSpPr>
+          <p:cNvPr id="12" name="Text 10"/>
+          <p:cNvSpPr/>
+          <p:nvPr/>
+        </p:nvSpPr>
+        <p:spPr>
+          <a:xfrm>
+            <a:off x="6263640" y="3785616"/>
+            <a:ext cx="5532120" cy="1417320"/>
           </a:xfrm>
           <a:prstGeom prst="rect">
             <a:avLst/>
@@ -3891,95 +4431,17 @@
               <a:buNone/>
             </a:pPr>
             <a:r>
-              <a:rPr lang="en-US" sz="1500" dirty="0">
-                <a:solidFill>
-                  <a:srgbClr val="5C5C5C"/>
-                </a:solidFill>
-                <a:latin typeface="Arial" pitchFamily="34" charset="0"/>
-                <a:ea typeface="Arial" pitchFamily="34" charset="-122"/>
-                <a:cs typeface="Arial" pitchFamily="34" charset="-120"/>
-              </a:rPr>
-              <a:t>Earlier shared API examples and short decision notes after scope discussions, so fewer surprises late in the term.</a:t>
-            </a:r>
-            <a:endParaRPr lang="en-US" sz="1500" dirty="0"/>
-          </a:p>
-        </p:txBody>
-      </p:sp>
-      <p:sp>
-        <p:nvSpPr>
-          <p:cNvPr id="10" name="Text 8"/>
-          <p:cNvSpPr/>
-          <p:nvPr/>
-        </p:nvSpPr>
-        <p:spPr>
-          <a:xfrm>
-            <a:off x="6080760" y="3611880"/>
-            <a:ext cx="5669280" cy="365760"/>
-          </a:xfrm>
-          <a:prstGeom prst="rect">
-            <a:avLst/>
-          </a:prstGeom>
-          <a:noFill/>
-          <a:ln/>
-        </p:spPr>
-        <p:txBody>
-          <a:bodyPr wrap="square" rtlCol="0" anchor="ctr"/>
-          <a:lstStyle/>
-          <a:p>
-            <a:pPr indent="0" marL="0">
-              <a:buNone/>
-            </a:pPr>
-            <a:r>
-              <a:rPr lang="en-US" sz="1800" b="1" dirty="0">
-                <a:solidFill>
-                  <a:srgbClr val="0A0A0A"/>
-                </a:solidFill>
-                <a:latin typeface="Arial" pitchFamily="34" charset="0"/>
-                <a:ea typeface="Arial" pitchFamily="34" charset="-122"/>
-                <a:cs typeface="Arial" pitchFamily="34" charset="-120"/>
-              </a:rPr>
-              <a:t>Reviews</a:t>
-            </a:r>
-            <a:endParaRPr lang="en-US" sz="1800" dirty="0"/>
-          </a:p>
-        </p:txBody>
-      </p:sp>
-      <p:sp>
-        <p:nvSpPr>
-          <p:cNvPr id="11" name="Text 9"/>
-          <p:cNvSpPr/>
-          <p:nvPr/>
-        </p:nvSpPr>
-        <p:spPr>
-          <a:xfrm>
-            <a:off x="6080760" y="4023360"/>
-            <a:ext cx="5669280" cy="1371600"/>
-          </a:xfrm>
-          <a:prstGeom prst="rect">
-            <a:avLst/>
-          </a:prstGeom>
-          <a:noFill/>
-          <a:ln/>
-        </p:spPr>
-        <p:txBody>
-          <a:bodyPr wrap="square" rtlCol="0" anchor="t"/>
-          <a:lstStyle/>
-          <a:p>
-            <a:pPr indent="0" marL="0">
-              <a:buNone/>
-            </a:pPr>
-            <a:r>
-              <a:rPr lang="en-US" sz="1500" dirty="0">
-                <a:solidFill>
-                  <a:srgbClr val="5C5C5C"/>
-                </a:solidFill>
-                <a:latin typeface="Arial" pitchFamily="34" charset="0"/>
-                <a:ea typeface="Arial" pitchFamily="34" charset="-122"/>
-                <a:cs typeface="Arial" pitchFamily="34" charset="-120"/>
+              <a:rPr lang="en-US" sz="1400" dirty="0">
+                <a:solidFill>
+                  <a:srgbClr val="6A6A6A"/>
+                </a:solidFill>
+                <a:latin typeface="Calibri" pitchFamily="34" charset="0"/>
+                <a:ea typeface="Calibri" pitchFamily="34" charset="-122"/>
+                <a:cs typeface="Calibri" pitchFamily="34" charset="-120"/>
               </a:rPr>
               <a:t>PR comments on behavior and security (auth, uploads); sync for blockers, async for the rest.</a:t>
             </a:r>
-            <a:endParaRPr lang="en-US" sz="1500" dirty="0"/>
+            <a:endParaRPr lang="en-US" sz="1400" dirty="0"/>
           </a:p>
         </p:txBody>
       </p:sp>

</xml_diff>